<commit_message>
feat: add backend API, bilingual support, ElevenLabs voice, Vercel deploy
- 4 serverless API endpoints (products, orders, contact, health)
- Bilingual ES/EN toggle (no flags)
- ElevenLabs voice widget in chatbot
- vercel.json for routing
- Deployed to Vercel

Co-Authored-By: Claude Opus 4.6 (1M context) <noreply@anthropic.com>
</commit_message>
<xml_diff>
--- a/Lobos_de_Montana_Presentacion.pptx
+++ b/Lobos_de_Montana_Presentacion.pptx
@@ -3102,9 +3102,35 @@
         <p:nvPr/>
       </p:nvGrpSpPr>
       <p:grpSpPr/>
-      <p:sp>
-        <p:nvSpPr>
-          <p:cNvPr id="2" name="Rectangle 1"/>
+      <p:pic>
+        <p:nvPicPr>
+          <p:cNvPr id="2" name="Picture 1" descr="logo-wolf.png"/>
+          <p:cNvPicPr>
+            <a:picLocks noChangeAspect="1"/>
+          </p:cNvPicPr>
+          <p:nvPr/>
+        </p:nvPicPr>
+        <p:blipFill>
+          <a:blip r:embed="rId2">
+            <a:alphaModFix amt="8000"/>
+          </a:blip>
+          <a:stretch>
+            <a:fillRect/>
+          </a:stretch>
+        </p:blipFill>
+        <p:spPr>
+          <a:xfrm>
+            <a:off x="3840480" y="1371600"/>
+            <a:ext cx="4572000" cy="4572000"/>
+          </a:xfrm>
+          <a:prstGeom prst="rect">
+            <a:avLst/>
+          </a:prstGeom>
+        </p:spPr>
+      </p:pic>
+      <p:sp>
+        <p:nvSpPr>
+          <p:cNvPr id="3" name="Rectangle 2"/>
           <p:cNvSpPr/>
           <p:nvPr/>
         </p:nvSpPr>
@@ -3149,7 +3175,7 @@
       </p:sp>
       <p:sp>
         <p:nvSpPr>
-          <p:cNvPr id="3" name="Rectangle 2"/>
+          <p:cNvPr id="4" name="Rectangle 3"/>
           <p:cNvSpPr/>
           <p:nvPr/>
         </p:nvSpPr>
@@ -3194,7 +3220,7 @@
       </p:sp>
       <p:sp>
         <p:nvSpPr>
-          <p:cNvPr id="4" name="Oval 3"/>
+          <p:cNvPr id="5" name="Oval 4"/>
           <p:cNvSpPr/>
           <p:nvPr/>
         </p:nvSpPr>
@@ -3239,7 +3265,7 @@
       </p:sp>
       <p:sp>
         <p:nvSpPr>
-          <p:cNvPr id="5" name="Oval 4"/>
+          <p:cNvPr id="6" name="Oval 5"/>
           <p:cNvSpPr/>
           <p:nvPr/>
         </p:nvSpPr>
@@ -3284,7 +3310,7 @@
       </p:sp>
       <p:sp>
         <p:nvSpPr>
-          <p:cNvPr id="6" name="Oval 5"/>
+          <p:cNvPr id="7" name="Oval 6"/>
           <p:cNvSpPr/>
           <p:nvPr/>
         </p:nvSpPr>
@@ -3329,7 +3355,7 @@
       </p:sp>
       <p:sp>
         <p:nvSpPr>
-          <p:cNvPr id="7" name="Oval 6"/>
+          <p:cNvPr id="8" name="Oval 7"/>
           <p:cNvSpPr/>
           <p:nvPr/>
         </p:nvSpPr>
@@ -3374,7 +3400,7 @@
       </p:sp>
       <p:sp>
         <p:nvSpPr>
-          <p:cNvPr id="8" name="Oval 7"/>
+          <p:cNvPr id="9" name="Oval 8"/>
           <p:cNvSpPr/>
           <p:nvPr/>
         </p:nvSpPr>
@@ -3419,7 +3445,7 @@
       </p:sp>
       <p:sp>
         <p:nvSpPr>
-          <p:cNvPr id="9" name="Oval 8"/>
+          <p:cNvPr id="10" name="Oval 9"/>
           <p:cNvSpPr/>
           <p:nvPr/>
         </p:nvSpPr>
@@ -3464,7 +3490,7 @@
       </p:sp>
       <p:sp>
         <p:nvSpPr>
-          <p:cNvPr id="10" name="Oval 9"/>
+          <p:cNvPr id="11" name="Oval 10"/>
           <p:cNvSpPr/>
           <p:nvPr/>
         </p:nvSpPr>
@@ -3509,7 +3535,7 @@
       </p:sp>
       <p:sp>
         <p:nvSpPr>
-          <p:cNvPr id="11" name="Oval 10"/>
+          <p:cNvPr id="12" name="Oval 11"/>
           <p:cNvSpPr/>
           <p:nvPr/>
         </p:nvSpPr>
@@ -3554,7 +3580,7 @@
       </p:sp>
       <p:sp>
         <p:nvSpPr>
-          <p:cNvPr id="12" name="Oval 11"/>
+          <p:cNvPr id="13" name="Oval 12"/>
           <p:cNvSpPr/>
           <p:nvPr/>
         </p:nvSpPr>
@@ -3599,7 +3625,7 @@
       </p:sp>
       <p:sp>
         <p:nvSpPr>
-          <p:cNvPr id="13" name="Oval 12"/>
+          <p:cNvPr id="14" name="Oval 13"/>
           <p:cNvSpPr/>
           <p:nvPr/>
         </p:nvSpPr>
@@ -3644,7 +3670,7 @@
       </p:sp>
       <p:sp>
         <p:nvSpPr>
-          <p:cNvPr id="14" name="Oval 13"/>
+          <p:cNvPr id="15" name="Oval 14"/>
           <p:cNvSpPr/>
           <p:nvPr/>
         </p:nvSpPr>
@@ -3689,7 +3715,7 @@
       </p:sp>
       <p:sp>
         <p:nvSpPr>
-          <p:cNvPr id="15" name="Oval 14"/>
+          <p:cNvPr id="16" name="Oval 15"/>
           <p:cNvSpPr/>
           <p:nvPr/>
         </p:nvSpPr>
@@ -3734,7 +3760,7 @@
       </p:sp>
       <p:sp>
         <p:nvSpPr>
-          <p:cNvPr id="16" name="Oval 15"/>
+          <p:cNvPr id="17" name="Oval 16"/>
           <p:cNvSpPr/>
           <p:nvPr/>
         </p:nvSpPr>
@@ -3779,7 +3805,7 @@
       </p:sp>
       <p:sp>
         <p:nvSpPr>
-          <p:cNvPr id="17" name="Oval 16"/>
+          <p:cNvPr id="18" name="Oval 17"/>
           <p:cNvSpPr/>
           <p:nvPr/>
         </p:nvSpPr>
@@ -3824,7 +3850,7 @@
       </p:sp>
       <p:sp>
         <p:nvSpPr>
-          <p:cNvPr id="18" name="Oval 17"/>
+          <p:cNvPr id="19" name="Oval 18"/>
           <p:cNvSpPr/>
           <p:nvPr/>
         </p:nvSpPr>
@@ -3869,7 +3895,7 @@
       </p:sp>
       <p:sp>
         <p:nvSpPr>
-          <p:cNvPr id="19" name="Oval 18"/>
+          <p:cNvPr id="20" name="Oval 19"/>
           <p:cNvSpPr/>
           <p:nvPr/>
         </p:nvSpPr>
@@ -3914,7 +3940,7 @@
       </p:sp>
       <p:sp>
         <p:nvSpPr>
-          <p:cNvPr id="20" name="Oval 19"/>
+          <p:cNvPr id="21" name="Oval 20"/>
           <p:cNvSpPr/>
           <p:nvPr/>
         </p:nvSpPr>
@@ -3959,7 +3985,7 @@
       </p:sp>
       <p:sp>
         <p:nvSpPr>
-          <p:cNvPr id="21" name="Oval 20"/>
+          <p:cNvPr id="22" name="Oval 21"/>
           <p:cNvSpPr/>
           <p:nvPr/>
         </p:nvSpPr>
@@ -4004,7 +4030,7 @@
       </p:sp>
       <p:sp>
         <p:nvSpPr>
-          <p:cNvPr id="22" name="Oval 21"/>
+          <p:cNvPr id="23" name="Oval 22"/>
           <p:cNvSpPr/>
           <p:nvPr/>
         </p:nvSpPr>
@@ -4049,7 +4075,7 @@
       </p:sp>
       <p:sp>
         <p:nvSpPr>
-          <p:cNvPr id="23" name="Oval 22"/>
+          <p:cNvPr id="24" name="Oval 23"/>
           <p:cNvSpPr/>
           <p:nvPr/>
         </p:nvSpPr>
@@ -4094,7 +4120,7 @@
       </p:sp>
       <p:sp>
         <p:nvSpPr>
-          <p:cNvPr id="24" name="Oval 23"/>
+          <p:cNvPr id="25" name="Oval 24"/>
           <p:cNvSpPr/>
           <p:nvPr/>
         </p:nvSpPr>
@@ -4139,7 +4165,7 @@
       </p:sp>
       <p:sp>
         <p:nvSpPr>
-          <p:cNvPr id="25" name="Oval 24"/>
+          <p:cNvPr id="26" name="Oval 25"/>
           <p:cNvSpPr/>
           <p:nvPr/>
         </p:nvSpPr>
@@ -4184,7 +4210,7 @@
       </p:sp>
       <p:sp>
         <p:nvSpPr>
-          <p:cNvPr id="26" name="Oval 25"/>
+          <p:cNvPr id="27" name="Oval 26"/>
           <p:cNvSpPr/>
           <p:nvPr/>
         </p:nvSpPr>
@@ -4229,7 +4255,7 @@
       </p:sp>
       <p:sp>
         <p:nvSpPr>
-          <p:cNvPr id="27" name="Oval 26"/>
+          <p:cNvPr id="28" name="Oval 27"/>
           <p:cNvSpPr/>
           <p:nvPr/>
         </p:nvSpPr>
@@ -4274,7 +4300,7 @@
       </p:sp>
       <p:sp>
         <p:nvSpPr>
-          <p:cNvPr id="28" name="Oval 27"/>
+          <p:cNvPr id="29" name="Oval 28"/>
           <p:cNvSpPr/>
           <p:nvPr/>
         </p:nvSpPr>
@@ -4319,7 +4345,7 @@
       </p:sp>
       <p:sp>
         <p:nvSpPr>
-          <p:cNvPr id="29" name="Oval 28"/>
+          <p:cNvPr id="30" name="Oval 29"/>
           <p:cNvSpPr/>
           <p:nvPr/>
         </p:nvSpPr>
@@ -4364,7 +4390,7 @@
       </p:sp>
       <p:sp>
         <p:nvSpPr>
-          <p:cNvPr id="30" name="Oval 29"/>
+          <p:cNvPr id="31" name="Oval 30"/>
           <p:cNvSpPr/>
           <p:nvPr/>
         </p:nvSpPr>
@@ -4409,7 +4435,7 @@
       </p:sp>
       <p:sp>
         <p:nvSpPr>
-          <p:cNvPr id="31" name="Oval 30"/>
+          <p:cNvPr id="32" name="Oval 31"/>
           <p:cNvSpPr/>
           <p:nvPr/>
         </p:nvSpPr>
@@ -4454,7 +4480,7 @@
       </p:sp>
       <p:sp>
         <p:nvSpPr>
-          <p:cNvPr id="32" name="Oval 31"/>
+          <p:cNvPr id="33" name="Oval 32"/>
           <p:cNvSpPr/>
           <p:nvPr/>
         </p:nvSpPr>
@@ -4499,7 +4525,7 @@
       </p:sp>
       <p:sp>
         <p:nvSpPr>
-          <p:cNvPr id="33" name="Oval 32"/>
+          <p:cNvPr id="34" name="Oval 33"/>
           <p:cNvSpPr/>
           <p:nvPr/>
         </p:nvSpPr>
@@ -4544,7 +4570,7 @@
       </p:sp>
       <p:sp>
         <p:nvSpPr>
-          <p:cNvPr id="34" name="Oval 33"/>
+          <p:cNvPr id="35" name="Oval 34"/>
           <p:cNvSpPr/>
           <p:nvPr/>
         </p:nvSpPr>
@@ -4589,7 +4615,7 @@
       </p:sp>
       <p:sp>
         <p:nvSpPr>
-          <p:cNvPr id="35" name="Oval 34"/>
+          <p:cNvPr id="36" name="Oval 35"/>
           <p:cNvSpPr/>
           <p:nvPr/>
         </p:nvSpPr>
@@ -4634,7 +4660,7 @@
       </p:sp>
       <p:sp>
         <p:nvSpPr>
-          <p:cNvPr id="36" name="Oval 35"/>
+          <p:cNvPr id="37" name="Oval 36"/>
           <p:cNvSpPr/>
           <p:nvPr/>
         </p:nvSpPr>
@@ -4679,7 +4705,7 @@
       </p:sp>
       <p:sp>
         <p:nvSpPr>
-          <p:cNvPr id="37" name="Oval 36"/>
+          <p:cNvPr id="38" name="Oval 37"/>
           <p:cNvSpPr/>
           <p:nvPr/>
         </p:nvSpPr>
@@ -4724,7 +4750,7 @@
       </p:sp>
       <p:sp>
         <p:nvSpPr>
-          <p:cNvPr id="38" name="Oval 37"/>
+          <p:cNvPr id="39" name="Oval 38"/>
           <p:cNvSpPr/>
           <p:nvPr/>
         </p:nvSpPr>
@@ -4769,7 +4795,7 @@
       </p:sp>
       <p:sp>
         <p:nvSpPr>
-          <p:cNvPr id="39" name="Oval 38"/>
+          <p:cNvPr id="40" name="Oval 39"/>
           <p:cNvSpPr/>
           <p:nvPr/>
         </p:nvSpPr>
@@ -4814,7 +4840,7 @@
       </p:sp>
       <p:sp>
         <p:nvSpPr>
-          <p:cNvPr id="40" name="Oval 39"/>
+          <p:cNvPr id="41" name="Oval 40"/>
           <p:cNvSpPr/>
           <p:nvPr/>
         </p:nvSpPr>
@@ -4859,7 +4885,7 @@
       </p:sp>
       <p:sp>
         <p:nvSpPr>
-          <p:cNvPr id="41" name="Oval 40"/>
+          <p:cNvPr id="42" name="Oval 41"/>
           <p:cNvSpPr/>
           <p:nvPr/>
         </p:nvSpPr>
@@ -4904,7 +4930,7 @@
       </p:sp>
       <p:sp>
         <p:nvSpPr>
-          <p:cNvPr id="42" name="Oval 41"/>
+          <p:cNvPr id="43" name="Oval 42"/>
           <p:cNvSpPr/>
           <p:nvPr/>
         </p:nvSpPr>
@@ -4949,7 +4975,7 @@
       </p:sp>
       <p:sp>
         <p:nvSpPr>
-          <p:cNvPr id="43" name="Oval 42"/>
+          <p:cNvPr id="44" name="Oval 43"/>
           <p:cNvSpPr/>
           <p:nvPr/>
         </p:nvSpPr>
@@ -4994,7 +5020,7 @@
       </p:sp>
       <p:sp>
         <p:nvSpPr>
-          <p:cNvPr id="44" name="Oval 43"/>
+          <p:cNvPr id="45" name="Oval 44"/>
           <p:cNvSpPr/>
           <p:nvPr/>
         </p:nvSpPr>
@@ -5039,7 +5065,7 @@
       </p:sp>
       <p:sp>
         <p:nvSpPr>
-          <p:cNvPr id="45" name="Oval 44"/>
+          <p:cNvPr id="46" name="Oval 45"/>
           <p:cNvSpPr/>
           <p:nvPr/>
         </p:nvSpPr>
@@ -5084,7 +5110,7 @@
       </p:sp>
       <p:sp>
         <p:nvSpPr>
-          <p:cNvPr id="46" name="Oval 45"/>
+          <p:cNvPr id="47" name="Oval 46"/>
           <p:cNvSpPr/>
           <p:nvPr/>
         </p:nvSpPr>
@@ -5129,7 +5155,7 @@
       </p:sp>
       <p:sp>
         <p:nvSpPr>
-          <p:cNvPr id="47" name="Oval 46"/>
+          <p:cNvPr id="48" name="Oval 47"/>
           <p:cNvSpPr/>
           <p:nvPr/>
         </p:nvSpPr>
@@ -5174,7 +5200,7 @@
       </p:sp>
       <p:sp>
         <p:nvSpPr>
-          <p:cNvPr id="48" name="Oval 47"/>
+          <p:cNvPr id="49" name="Oval 48"/>
           <p:cNvSpPr/>
           <p:nvPr/>
         </p:nvSpPr>
@@ -5219,7 +5245,7 @@
       </p:sp>
       <p:sp>
         <p:nvSpPr>
-          <p:cNvPr id="49" name="Oval 48"/>
+          <p:cNvPr id="50" name="Oval 49"/>
           <p:cNvSpPr/>
           <p:nvPr/>
         </p:nvSpPr>
@@ -5264,7 +5290,7 @@
       </p:sp>
       <p:sp>
         <p:nvSpPr>
-          <p:cNvPr id="50" name="Oval 49"/>
+          <p:cNvPr id="51" name="Oval 50"/>
           <p:cNvSpPr/>
           <p:nvPr/>
         </p:nvSpPr>
@@ -5309,7 +5335,7 @@
       </p:sp>
       <p:sp>
         <p:nvSpPr>
-          <p:cNvPr id="51" name="Oval 50"/>
+          <p:cNvPr id="52" name="Oval 51"/>
           <p:cNvSpPr/>
           <p:nvPr/>
         </p:nvSpPr>
@@ -5354,7 +5380,7 @@
       </p:sp>
       <p:sp>
         <p:nvSpPr>
-          <p:cNvPr id="52" name="Oval 51"/>
+          <p:cNvPr id="53" name="Oval 52"/>
           <p:cNvSpPr/>
           <p:nvPr/>
         </p:nvSpPr>
@@ -5399,7 +5425,7 @@
       </p:sp>
       <p:sp>
         <p:nvSpPr>
-          <p:cNvPr id="53" name="Oval 52"/>
+          <p:cNvPr id="54" name="Oval 53"/>
           <p:cNvSpPr/>
           <p:nvPr/>
         </p:nvSpPr>
@@ -5444,7 +5470,7 @@
       </p:sp>
       <p:pic>
         <p:nvPicPr>
-          <p:cNvPr id="54" name="Picture 53" descr="logo-wolf.png"/>
+          <p:cNvPr id="55" name="Picture 54" descr="logo-wolf.png"/>
           <p:cNvPicPr>
             <a:picLocks noChangeAspect="1"/>
           </p:cNvPicPr>
@@ -5468,7 +5494,7 @@
       </p:pic>
       <p:sp>
         <p:nvSpPr>
-          <p:cNvPr id="55" name="Rectangle 54"/>
+          <p:cNvPr id="56" name="Rectangle 55"/>
           <p:cNvSpPr/>
           <p:nvPr/>
         </p:nvSpPr>
@@ -5511,7 +5537,7 @@
       </p:sp>
       <p:sp>
         <p:nvSpPr>
-          <p:cNvPr id="56" name="Rectangle 55"/>
+          <p:cNvPr id="57" name="Rectangle 56"/>
           <p:cNvSpPr/>
           <p:nvPr/>
         </p:nvSpPr>
@@ -5554,7 +5580,7 @@
       </p:sp>
       <p:sp>
         <p:nvSpPr>
-          <p:cNvPr id="57" name="TextBox 56"/>
+          <p:cNvPr id="58" name="TextBox 57"/>
           <p:cNvSpPr txBox="1"/>
           <p:nvPr/>
         </p:nvSpPr>
@@ -5575,7 +5601,7 @@
           <a:lstStyle/>
           <a:p>
             <a:pPr algn="ctr">
-              <a:defRPr sz="6800" b="1" i="0">
+              <a:defRPr sz="8000" b="1" i="0">
                 <a:solidFill>
                   <a:srgbClr val="FFFFFF"/>
                 </a:solidFill>
@@ -5590,7 +5616,7 @@
       </p:sp>
       <p:sp>
         <p:nvSpPr>
-          <p:cNvPr id="58" name="Rectangle 57"/>
+          <p:cNvPr id="59" name="Rectangle 58"/>
           <p:cNvSpPr/>
           <p:nvPr/>
         </p:nvSpPr>
@@ -5633,7 +5659,7 @@
       </p:sp>
       <p:sp>
         <p:nvSpPr>
-          <p:cNvPr id="59" name="Rectangle 58"/>
+          <p:cNvPr id="60" name="Rectangle 59"/>
           <p:cNvSpPr/>
           <p:nvPr/>
         </p:nvSpPr>
@@ -5676,7 +5702,7 @@
       </p:sp>
       <p:sp>
         <p:nvSpPr>
-          <p:cNvPr id="60" name="TextBox 59"/>
+          <p:cNvPr id="61" name="TextBox 60"/>
           <p:cNvSpPr txBox="1"/>
           <p:nvPr/>
         </p:nvSpPr>
@@ -5697,7 +5723,7 @@
           <a:lstStyle/>
           <a:p>
             <a:pPr algn="ctr">
-              <a:defRPr sz="2400" b="0" i="1">
+              <a:defRPr sz="2800" b="0" i="1">
                 <a:solidFill>
                   <a:srgbClr val="A9C0DE"/>
                 </a:solidFill>
@@ -5712,7 +5738,7 @@
       </p:sp>
       <p:sp>
         <p:nvSpPr>
-          <p:cNvPr id="61" name="TextBox 60"/>
+          <p:cNvPr id="62" name="TextBox 61"/>
           <p:cNvSpPr txBox="1"/>
           <p:nvPr/>
         </p:nvSpPr>
@@ -5733,7 +5759,7 @@
           <a:lstStyle/>
           <a:p>
             <a:pPr algn="ctr">
-              <a:defRPr sz="1500" b="0" i="0">
+              <a:defRPr sz="1800" b="0" i="0">
                 <a:solidFill>
                   <a:srgbClr val="D3DFE8"/>
                 </a:solidFill>
@@ -5748,7 +5774,7 @@
       </p:sp>
       <p:sp>
         <p:nvSpPr>
-          <p:cNvPr id="62" name="Rectangle 61"/>
+          <p:cNvPr id="63" name="Rectangle 62"/>
           <p:cNvSpPr/>
           <p:nvPr/>
         </p:nvSpPr>
@@ -5791,7 +5817,7 @@
       </p:sp>
       <p:sp>
         <p:nvSpPr>
-          <p:cNvPr id="63" name="TextBox 62"/>
+          <p:cNvPr id="64" name="TextBox 63"/>
           <p:cNvSpPr txBox="1"/>
           <p:nvPr/>
         </p:nvSpPr>
@@ -5851,9 +5877,35 @@
         <p:nvPr/>
       </p:nvGrpSpPr>
       <p:grpSpPr/>
-      <p:sp>
-        <p:nvSpPr>
-          <p:cNvPr id="2" name="Rectangle 1"/>
+      <p:pic>
+        <p:nvPicPr>
+          <p:cNvPr id="2" name="Picture 1" descr="logo-wolf.png"/>
+          <p:cNvPicPr>
+            <a:picLocks noChangeAspect="1"/>
+          </p:cNvPicPr>
+          <p:nvPr/>
+        </p:nvPicPr>
+        <p:blipFill>
+          <a:blip r:embed="rId2">
+            <a:alphaModFix amt="8000"/>
+          </a:blip>
+          <a:stretch>
+            <a:fillRect/>
+          </a:stretch>
+        </p:blipFill>
+        <p:spPr>
+          <a:xfrm>
+            <a:off x="3840480" y="1371600"/>
+            <a:ext cx="4572000" cy="4572000"/>
+          </a:xfrm>
+          <a:prstGeom prst="rect">
+            <a:avLst/>
+          </a:prstGeom>
+        </p:spPr>
+      </p:pic>
+      <p:sp>
+        <p:nvSpPr>
+          <p:cNvPr id="3" name="Rectangle 2"/>
           <p:cNvSpPr/>
           <p:nvPr/>
         </p:nvSpPr>
@@ -5898,7 +5950,7 @@
       </p:sp>
       <p:sp>
         <p:nvSpPr>
-          <p:cNvPr id="3" name="Rectangle 2"/>
+          <p:cNvPr id="4" name="Rectangle 3"/>
           <p:cNvSpPr/>
           <p:nvPr/>
         </p:nvSpPr>
@@ -5943,7 +5995,7 @@
       </p:sp>
       <p:sp>
         <p:nvSpPr>
-          <p:cNvPr id="4" name="Rectangle 3"/>
+          <p:cNvPr id="5" name="Rectangle 4"/>
           <p:cNvSpPr/>
           <p:nvPr/>
         </p:nvSpPr>
@@ -5988,7 +6040,7 @@
       </p:sp>
       <p:sp>
         <p:nvSpPr>
-          <p:cNvPr id="5" name="Rectangle 4"/>
+          <p:cNvPr id="6" name="Rectangle 5"/>
           <p:cNvSpPr/>
           <p:nvPr/>
         </p:nvSpPr>
@@ -6031,7 +6083,7 @@
       </p:sp>
       <p:sp>
         <p:nvSpPr>
-          <p:cNvPr id="6" name="Oval 5"/>
+          <p:cNvPr id="7" name="Oval 6"/>
           <p:cNvSpPr/>
           <p:nvPr/>
         </p:nvSpPr>
@@ -6076,7 +6128,7 @@
       </p:sp>
       <p:sp>
         <p:nvSpPr>
-          <p:cNvPr id="7" name="Oval 6"/>
+          <p:cNvPr id="8" name="Oval 7"/>
           <p:cNvSpPr/>
           <p:nvPr/>
         </p:nvSpPr>
@@ -6121,7 +6173,7 @@
       </p:sp>
       <p:sp>
         <p:nvSpPr>
-          <p:cNvPr id="8" name="Oval 7"/>
+          <p:cNvPr id="9" name="Oval 8"/>
           <p:cNvSpPr/>
           <p:nvPr/>
         </p:nvSpPr>
@@ -6166,7 +6218,7 @@
       </p:sp>
       <p:sp>
         <p:nvSpPr>
-          <p:cNvPr id="9" name="Oval 8"/>
+          <p:cNvPr id="10" name="Oval 9"/>
           <p:cNvSpPr/>
           <p:nvPr/>
         </p:nvSpPr>
@@ -6211,7 +6263,7 @@
       </p:sp>
       <p:sp>
         <p:nvSpPr>
-          <p:cNvPr id="10" name="Rectangle 9"/>
+          <p:cNvPr id="11" name="Rectangle 10"/>
           <p:cNvSpPr/>
           <p:nvPr/>
         </p:nvSpPr>
@@ -6254,7 +6306,7 @@
       </p:sp>
       <p:sp>
         <p:nvSpPr>
-          <p:cNvPr id="11" name="TextBox 10"/>
+          <p:cNvPr id="12" name="TextBox 11"/>
           <p:cNvSpPr txBox="1"/>
           <p:nvPr/>
         </p:nvSpPr>
@@ -6290,7 +6342,7 @@
       </p:sp>
       <p:sp>
         <p:nvSpPr>
-          <p:cNvPr id="12" name="TextBox 11"/>
+          <p:cNvPr id="13" name="TextBox 12"/>
           <p:cNvSpPr txBox="1"/>
           <p:nvPr/>
         </p:nvSpPr>
@@ -6311,7 +6363,7 @@
           <a:lstStyle/>
           <a:p>
             <a:pPr algn="l">
-              <a:defRPr sz="3800" b="1" i="1">
+              <a:defRPr sz="4400" b="1" i="1">
                 <a:solidFill>
                   <a:srgbClr val="FFFFFF"/>
                 </a:solidFill>
@@ -6330,7 +6382,7 @@
       </p:sp>
       <p:sp>
         <p:nvSpPr>
-          <p:cNvPr id="13" name="Rectangle 12"/>
+          <p:cNvPr id="14" name="Rectangle 13"/>
           <p:cNvSpPr/>
           <p:nvPr/>
         </p:nvSpPr>
@@ -6373,7 +6425,7 @@
       </p:sp>
       <p:sp>
         <p:nvSpPr>
-          <p:cNvPr id="14" name="Rectangle 13"/>
+          <p:cNvPr id="15" name="Rectangle 14"/>
           <p:cNvSpPr/>
           <p:nvPr/>
         </p:nvSpPr>
@@ -6416,7 +6468,7 @@
       </p:sp>
       <p:sp>
         <p:nvSpPr>
-          <p:cNvPr id="15" name="Rounded Rectangle 14"/>
+          <p:cNvPr id="16" name="Rounded Rectangle 15"/>
           <p:cNvSpPr/>
           <p:nvPr/>
         </p:nvSpPr>
@@ -6461,7 +6513,7 @@
       </p:sp>
       <p:sp>
         <p:nvSpPr>
-          <p:cNvPr id="16" name="Rectangle 15"/>
+          <p:cNvPr id="17" name="Rectangle 16"/>
           <p:cNvSpPr/>
           <p:nvPr/>
         </p:nvSpPr>
@@ -6504,7 +6556,7 @@
       </p:sp>
       <p:sp>
         <p:nvSpPr>
-          <p:cNvPr id="17" name="Oval 16"/>
+          <p:cNvPr id="18" name="Oval 17"/>
           <p:cNvSpPr/>
           <p:nvPr/>
         </p:nvSpPr>
@@ -6549,7 +6601,7 @@
       </p:sp>
       <p:sp>
         <p:nvSpPr>
-          <p:cNvPr id="18" name="TextBox 17"/>
+          <p:cNvPr id="19" name="TextBox 18"/>
           <p:cNvSpPr txBox="1"/>
           <p:nvPr/>
         </p:nvSpPr>
@@ -6585,7 +6637,7 @@
       </p:sp>
       <p:sp>
         <p:nvSpPr>
-          <p:cNvPr id="19" name="TextBox 18"/>
+          <p:cNvPr id="20" name="TextBox 19"/>
           <p:cNvSpPr txBox="1"/>
           <p:nvPr/>
         </p:nvSpPr>
@@ -6606,7 +6658,7 @@
           <a:lstStyle/>
           <a:p>
             <a:pPr algn="l">
-              <a:defRPr sz="1400" b="1" i="0">
+              <a:defRPr sz="1600" b="1" i="0">
                 <a:solidFill>
                   <a:srgbClr val="A9C0DE"/>
                 </a:solidFill>
@@ -6621,7 +6673,7 @@
       </p:sp>
       <p:sp>
         <p:nvSpPr>
-          <p:cNvPr id="20" name="TextBox 19"/>
+          <p:cNvPr id="21" name="TextBox 20"/>
           <p:cNvSpPr txBox="1"/>
           <p:nvPr/>
         </p:nvSpPr>
@@ -6642,7 +6694,7 @@
           <a:lstStyle/>
           <a:p>
             <a:pPr algn="l">
-              <a:defRPr sz="1100" b="0" i="0">
+              <a:defRPr sz="1300" b="0" i="0">
                 <a:solidFill>
                   <a:srgbClr val="D3DFE8"/>
                 </a:solidFill>
@@ -6657,7 +6709,7 @@
       </p:sp>
       <p:sp>
         <p:nvSpPr>
-          <p:cNvPr id="21" name="Rounded Rectangle 20"/>
+          <p:cNvPr id="22" name="Rounded Rectangle 21"/>
           <p:cNvSpPr/>
           <p:nvPr/>
         </p:nvSpPr>
@@ -6702,7 +6754,7 @@
       </p:sp>
       <p:sp>
         <p:nvSpPr>
-          <p:cNvPr id="22" name="Rectangle 21"/>
+          <p:cNvPr id="23" name="Rectangle 22"/>
           <p:cNvSpPr/>
           <p:nvPr/>
         </p:nvSpPr>
@@ -6745,7 +6797,7 @@
       </p:sp>
       <p:sp>
         <p:nvSpPr>
-          <p:cNvPr id="23" name="Oval 22"/>
+          <p:cNvPr id="24" name="Oval 23"/>
           <p:cNvSpPr/>
           <p:nvPr/>
         </p:nvSpPr>
@@ -6790,7 +6842,7 @@
       </p:sp>
       <p:sp>
         <p:nvSpPr>
-          <p:cNvPr id="24" name="TextBox 23"/>
+          <p:cNvPr id="25" name="TextBox 24"/>
           <p:cNvSpPr txBox="1"/>
           <p:nvPr/>
         </p:nvSpPr>
@@ -6826,7 +6878,7 @@
       </p:sp>
       <p:sp>
         <p:nvSpPr>
-          <p:cNvPr id="25" name="TextBox 24"/>
+          <p:cNvPr id="26" name="TextBox 25"/>
           <p:cNvSpPr txBox="1"/>
           <p:nvPr/>
         </p:nvSpPr>
@@ -6847,7 +6899,7 @@
           <a:lstStyle/>
           <a:p>
             <a:pPr algn="l">
-              <a:defRPr sz="1400" b="1" i="0">
+              <a:defRPr sz="1600" b="1" i="0">
                 <a:solidFill>
                   <a:srgbClr val="A9C0DE"/>
                 </a:solidFill>
@@ -6862,7 +6914,7 @@
       </p:sp>
       <p:sp>
         <p:nvSpPr>
-          <p:cNvPr id="26" name="TextBox 25"/>
+          <p:cNvPr id="27" name="TextBox 26"/>
           <p:cNvSpPr txBox="1"/>
           <p:nvPr/>
         </p:nvSpPr>
@@ -6883,7 +6935,7 @@
           <a:lstStyle/>
           <a:p>
             <a:pPr algn="l">
-              <a:defRPr sz="1100" b="0" i="0">
+              <a:defRPr sz="1300" b="0" i="0">
                 <a:solidFill>
                   <a:srgbClr val="D3DFE8"/>
                 </a:solidFill>
@@ -6898,7 +6950,7 @@
       </p:sp>
       <p:sp>
         <p:nvSpPr>
-          <p:cNvPr id="27" name="Rounded Rectangle 26"/>
+          <p:cNvPr id="28" name="Rounded Rectangle 27"/>
           <p:cNvSpPr/>
           <p:nvPr/>
         </p:nvSpPr>
@@ -6943,7 +6995,7 @@
       </p:sp>
       <p:sp>
         <p:nvSpPr>
-          <p:cNvPr id="28" name="Rectangle 27"/>
+          <p:cNvPr id="29" name="Rectangle 28"/>
           <p:cNvSpPr/>
           <p:nvPr/>
         </p:nvSpPr>
@@ -6986,7 +7038,7 @@
       </p:sp>
       <p:sp>
         <p:nvSpPr>
-          <p:cNvPr id="29" name="Oval 28"/>
+          <p:cNvPr id="30" name="Oval 29"/>
           <p:cNvSpPr/>
           <p:nvPr/>
         </p:nvSpPr>
@@ -7031,7 +7083,7 @@
       </p:sp>
       <p:sp>
         <p:nvSpPr>
-          <p:cNvPr id="30" name="TextBox 29"/>
+          <p:cNvPr id="31" name="TextBox 30"/>
           <p:cNvSpPr txBox="1"/>
           <p:nvPr/>
         </p:nvSpPr>
@@ -7067,7 +7119,7 @@
       </p:sp>
       <p:sp>
         <p:nvSpPr>
-          <p:cNvPr id="31" name="TextBox 30"/>
+          <p:cNvPr id="32" name="TextBox 31"/>
           <p:cNvSpPr txBox="1"/>
           <p:nvPr/>
         </p:nvSpPr>
@@ -7088,7 +7140,7 @@
           <a:lstStyle/>
           <a:p>
             <a:pPr algn="l">
-              <a:defRPr sz="1400" b="1" i="0">
+              <a:defRPr sz="1600" b="1" i="0">
                 <a:solidFill>
                   <a:srgbClr val="A9C0DE"/>
                 </a:solidFill>
@@ -7103,7 +7155,7 @@
       </p:sp>
       <p:sp>
         <p:nvSpPr>
-          <p:cNvPr id="32" name="TextBox 31"/>
+          <p:cNvPr id="33" name="TextBox 32"/>
           <p:cNvSpPr txBox="1"/>
           <p:nvPr/>
         </p:nvSpPr>
@@ -7124,7 +7176,7 @@
           <a:lstStyle/>
           <a:p>
             <a:pPr algn="l">
-              <a:defRPr sz="1100" b="0" i="0">
+              <a:defRPr sz="1300" b="0" i="0">
                 <a:solidFill>
                   <a:srgbClr val="D3DFE8"/>
                 </a:solidFill>
@@ -7139,7 +7191,7 @@
       </p:sp>
       <p:sp>
         <p:nvSpPr>
-          <p:cNvPr id="33" name="Oval 32"/>
+          <p:cNvPr id="34" name="Oval 33"/>
           <p:cNvSpPr/>
           <p:nvPr/>
         </p:nvSpPr>
@@ -7184,7 +7236,7 @@
       </p:sp>
       <p:sp>
         <p:nvSpPr>
-          <p:cNvPr id="34" name="Oval 33"/>
+          <p:cNvPr id="35" name="Oval 34"/>
           <p:cNvSpPr/>
           <p:nvPr/>
         </p:nvSpPr>
@@ -7229,7 +7281,7 @@
       </p:sp>
       <p:sp>
         <p:nvSpPr>
-          <p:cNvPr id="35" name="Oval 34"/>
+          <p:cNvPr id="36" name="Oval 35"/>
           <p:cNvSpPr/>
           <p:nvPr/>
         </p:nvSpPr>
@@ -7274,7 +7326,7 @@
       </p:sp>
       <p:sp>
         <p:nvSpPr>
-          <p:cNvPr id="36" name="Oval 35"/>
+          <p:cNvPr id="37" name="Oval 36"/>
           <p:cNvSpPr/>
           <p:nvPr/>
         </p:nvSpPr>
@@ -7319,7 +7371,7 @@
       </p:sp>
       <p:sp>
         <p:nvSpPr>
-          <p:cNvPr id="37" name="Oval 36"/>
+          <p:cNvPr id="38" name="Oval 37"/>
           <p:cNvSpPr/>
           <p:nvPr/>
         </p:nvSpPr>
@@ -7364,7 +7416,7 @@
       </p:sp>
       <p:sp>
         <p:nvSpPr>
-          <p:cNvPr id="38" name="Oval 37"/>
+          <p:cNvPr id="39" name="Oval 38"/>
           <p:cNvSpPr/>
           <p:nvPr/>
         </p:nvSpPr>
@@ -7409,7 +7461,7 @@
       </p:sp>
       <p:sp>
         <p:nvSpPr>
-          <p:cNvPr id="39" name="Oval 38"/>
+          <p:cNvPr id="40" name="Oval 39"/>
           <p:cNvSpPr/>
           <p:nvPr/>
         </p:nvSpPr>
@@ -7454,7 +7506,7 @@
       </p:sp>
       <p:sp>
         <p:nvSpPr>
-          <p:cNvPr id="40" name="Oval 39"/>
+          <p:cNvPr id="41" name="Oval 40"/>
           <p:cNvSpPr/>
           <p:nvPr/>
         </p:nvSpPr>
@@ -7499,7 +7551,7 @@
       </p:sp>
       <p:sp>
         <p:nvSpPr>
-          <p:cNvPr id="41" name="Oval 40"/>
+          <p:cNvPr id="42" name="Oval 41"/>
           <p:cNvSpPr/>
           <p:nvPr/>
         </p:nvSpPr>
@@ -7544,7 +7596,7 @@
       </p:sp>
       <p:sp>
         <p:nvSpPr>
-          <p:cNvPr id="42" name="Oval 41"/>
+          <p:cNvPr id="43" name="Oval 42"/>
           <p:cNvSpPr/>
           <p:nvPr/>
         </p:nvSpPr>
@@ -7589,7 +7641,7 @@
       </p:sp>
       <p:sp>
         <p:nvSpPr>
-          <p:cNvPr id="43" name="Oval 42"/>
+          <p:cNvPr id="44" name="Oval 43"/>
           <p:cNvSpPr/>
           <p:nvPr/>
         </p:nvSpPr>
@@ -7634,7 +7686,7 @@
       </p:sp>
       <p:sp>
         <p:nvSpPr>
-          <p:cNvPr id="44" name="Oval 43"/>
+          <p:cNvPr id="45" name="Oval 44"/>
           <p:cNvSpPr/>
           <p:nvPr/>
         </p:nvSpPr>
@@ -7679,7 +7731,7 @@
       </p:sp>
       <p:sp>
         <p:nvSpPr>
-          <p:cNvPr id="45" name="Oval 44"/>
+          <p:cNvPr id="46" name="Oval 45"/>
           <p:cNvSpPr/>
           <p:nvPr/>
         </p:nvSpPr>
@@ -7724,7 +7776,7 @@
       </p:sp>
       <p:sp>
         <p:nvSpPr>
-          <p:cNvPr id="46" name="Oval 45"/>
+          <p:cNvPr id="47" name="Oval 46"/>
           <p:cNvSpPr/>
           <p:nvPr/>
         </p:nvSpPr>
@@ -7769,7 +7821,7 @@
       </p:sp>
       <p:sp>
         <p:nvSpPr>
-          <p:cNvPr id="47" name="Oval 46"/>
+          <p:cNvPr id="48" name="Oval 47"/>
           <p:cNvSpPr/>
           <p:nvPr/>
         </p:nvSpPr>
@@ -7814,7 +7866,7 @@
       </p:sp>
       <p:sp>
         <p:nvSpPr>
-          <p:cNvPr id="48" name="Oval 47"/>
+          <p:cNvPr id="49" name="Oval 48"/>
           <p:cNvSpPr/>
           <p:nvPr/>
         </p:nvSpPr>
@@ -7859,7 +7911,7 @@
       </p:sp>
       <p:sp>
         <p:nvSpPr>
-          <p:cNvPr id="49" name="Oval 48"/>
+          <p:cNvPr id="50" name="Oval 49"/>
           <p:cNvSpPr/>
           <p:nvPr/>
         </p:nvSpPr>
@@ -7904,7 +7956,7 @@
       </p:sp>
       <p:sp>
         <p:nvSpPr>
-          <p:cNvPr id="50" name="Oval 49"/>
+          <p:cNvPr id="51" name="Oval 50"/>
           <p:cNvSpPr/>
           <p:nvPr/>
         </p:nvSpPr>
@@ -7949,7 +8001,7 @@
       </p:sp>
       <p:sp>
         <p:nvSpPr>
-          <p:cNvPr id="51" name="Oval 50"/>
+          <p:cNvPr id="52" name="Oval 51"/>
           <p:cNvSpPr/>
           <p:nvPr/>
         </p:nvSpPr>
@@ -7994,7 +8046,7 @@
       </p:sp>
       <p:sp>
         <p:nvSpPr>
-          <p:cNvPr id="52" name="Oval 51"/>
+          <p:cNvPr id="53" name="Oval 52"/>
           <p:cNvSpPr/>
           <p:nvPr/>
         </p:nvSpPr>
@@ -8039,7 +8091,7 @@
       </p:sp>
       <p:sp>
         <p:nvSpPr>
-          <p:cNvPr id="53" name="Oval 52"/>
+          <p:cNvPr id="54" name="Oval 53"/>
           <p:cNvSpPr/>
           <p:nvPr/>
         </p:nvSpPr>
@@ -8084,7 +8136,7 @@
       </p:sp>
       <p:sp>
         <p:nvSpPr>
-          <p:cNvPr id="54" name="Oval 53"/>
+          <p:cNvPr id="55" name="Oval 54"/>
           <p:cNvSpPr/>
           <p:nvPr/>
         </p:nvSpPr>
@@ -8129,7 +8181,7 @@
       </p:sp>
       <p:sp>
         <p:nvSpPr>
-          <p:cNvPr id="55" name="Oval 54"/>
+          <p:cNvPr id="56" name="Oval 55"/>
           <p:cNvSpPr/>
           <p:nvPr/>
         </p:nvSpPr>
@@ -8174,7 +8226,7 @@
       </p:sp>
       <p:sp>
         <p:nvSpPr>
-          <p:cNvPr id="56" name="Oval 55"/>
+          <p:cNvPr id="57" name="Oval 56"/>
           <p:cNvSpPr/>
           <p:nvPr/>
         </p:nvSpPr>
@@ -8219,7 +8271,7 @@
       </p:sp>
       <p:sp>
         <p:nvSpPr>
-          <p:cNvPr id="57" name="Rectangle 56"/>
+          <p:cNvPr id="58" name="Rectangle 57"/>
           <p:cNvSpPr/>
           <p:nvPr/>
         </p:nvSpPr>
@@ -8262,7 +8314,7 @@
       </p:sp>
       <p:sp>
         <p:nvSpPr>
-          <p:cNvPr id="58" name="TextBox 57"/>
+          <p:cNvPr id="59" name="TextBox 58"/>
           <p:cNvSpPr txBox="1"/>
           <p:nvPr/>
         </p:nvSpPr>
@@ -8298,7 +8350,7 @@
       </p:sp>
       <p:pic>
         <p:nvPicPr>
-          <p:cNvPr id="59" name="Picture 58" descr="logo-wolf.png"/>
+          <p:cNvPr id="60" name="Picture 59" descr="logo-wolf.png"/>
           <p:cNvPicPr>
             <a:picLocks noChangeAspect="1"/>
           </p:cNvPicPr>
@@ -8346,9 +8398,35 @@
         <p:nvPr/>
       </p:nvGrpSpPr>
       <p:grpSpPr/>
-      <p:sp>
-        <p:nvSpPr>
-          <p:cNvPr id="2" name="Rectangle 1"/>
+      <p:pic>
+        <p:nvPicPr>
+          <p:cNvPr id="2" name="Picture 1" descr="logo-wolf.png"/>
+          <p:cNvPicPr>
+            <a:picLocks noChangeAspect="1"/>
+          </p:cNvPicPr>
+          <p:nvPr/>
+        </p:nvPicPr>
+        <p:blipFill>
+          <a:blip r:embed="rId2">
+            <a:alphaModFix amt="8000"/>
+          </a:blip>
+          <a:stretch>
+            <a:fillRect/>
+          </a:stretch>
+        </p:blipFill>
+        <p:spPr>
+          <a:xfrm>
+            <a:off x="3840480" y="1371600"/>
+            <a:ext cx="4572000" cy="4572000"/>
+          </a:xfrm>
+          <a:prstGeom prst="rect">
+            <a:avLst/>
+          </a:prstGeom>
+        </p:spPr>
+      </p:pic>
+      <p:sp>
+        <p:nvSpPr>
+          <p:cNvPr id="3" name="Rectangle 2"/>
           <p:cNvSpPr/>
           <p:nvPr/>
         </p:nvSpPr>
@@ -8393,7 +8471,7 @@
       </p:sp>
       <p:sp>
         <p:nvSpPr>
-          <p:cNvPr id="3" name="Rectangle 2"/>
+          <p:cNvPr id="4" name="Rectangle 3"/>
           <p:cNvSpPr/>
           <p:nvPr/>
         </p:nvSpPr>
@@ -8438,7 +8516,7 @@
       </p:sp>
       <p:sp>
         <p:nvSpPr>
-          <p:cNvPr id="4" name="Rectangle 3"/>
+          <p:cNvPr id="5" name="Rectangle 4"/>
           <p:cNvSpPr/>
           <p:nvPr/>
         </p:nvSpPr>
@@ -8483,7 +8561,7 @@
       </p:sp>
       <p:sp>
         <p:nvSpPr>
-          <p:cNvPr id="5" name="Rectangle 4"/>
+          <p:cNvPr id="6" name="Rectangle 5"/>
           <p:cNvSpPr/>
           <p:nvPr/>
         </p:nvSpPr>
@@ -8526,7 +8604,7 @@
       </p:sp>
       <p:sp>
         <p:nvSpPr>
-          <p:cNvPr id="6" name="Oval 5"/>
+          <p:cNvPr id="7" name="Oval 6"/>
           <p:cNvSpPr/>
           <p:nvPr/>
         </p:nvSpPr>
@@ -8571,7 +8649,7 @@
       </p:sp>
       <p:sp>
         <p:nvSpPr>
-          <p:cNvPr id="7" name="Oval 6"/>
+          <p:cNvPr id="8" name="Oval 7"/>
           <p:cNvSpPr/>
           <p:nvPr/>
         </p:nvSpPr>
@@ -8616,7 +8694,7 @@
       </p:sp>
       <p:sp>
         <p:nvSpPr>
-          <p:cNvPr id="8" name="Oval 7"/>
+          <p:cNvPr id="9" name="Oval 8"/>
           <p:cNvSpPr/>
           <p:nvPr/>
         </p:nvSpPr>
@@ -8661,7 +8739,7 @@
       </p:sp>
       <p:sp>
         <p:nvSpPr>
-          <p:cNvPr id="9" name="Oval 8"/>
+          <p:cNvPr id="10" name="Oval 9"/>
           <p:cNvSpPr/>
           <p:nvPr/>
         </p:nvSpPr>
@@ -8706,7 +8784,7 @@
       </p:sp>
       <p:sp>
         <p:nvSpPr>
-          <p:cNvPr id="10" name="Rectangle 9"/>
+          <p:cNvPr id="11" name="Rectangle 10"/>
           <p:cNvSpPr/>
           <p:nvPr/>
         </p:nvSpPr>
@@ -8749,7 +8827,7 @@
       </p:sp>
       <p:sp>
         <p:nvSpPr>
-          <p:cNvPr id="11" name="TextBox 10"/>
+          <p:cNvPr id="12" name="TextBox 11"/>
           <p:cNvSpPr txBox="1"/>
           <p:nvPr/>
         </p:nvSpPr>
@@ -8785,7 +8863,7 @@
       </p:sp>
       <p:sp>
         <p:nvSpPr>
-          <p:cNvPr id="12" name="TextBox 11"/>
+          <p:cNvPr id="13" name="TextBox 12"/>
           <p:cNvSpPr txBox="1"/>
           <p:nvPr/>
         </p:nvSpPr>
@@ -8806,7 +8884,7 @@
           <a:lstStyle/>
           <a:p>
             <a:pPr algn="l">
-              <a:defRPr sz="1500" b="0" i="0">
+              <a:defRPr sz="1700" b="0" i="0">
                 <a:solidFill>
                   <a:srgbClr val="D3DFE8"/>
                 </a:solidFill>
@@ -8821,7 +8899,7 @@
       </p:sp>
       <p:sp>
         <p:nvSpPr>
-          <p:cNvPr id="13" name="Rectangle 12"/>
+          <p:cNvPr id="14" name="Rectangle 13"/>
           <p:cNvSpPr/>
           <p:nvPr/>
         </p:nvSpPr>
@@ -8864,7 +8942,7 @@
       </p:sp>
       <p:sp>
         <p:nvSpPr>
-          <p:cNvPr id="14" name="Rounded Rectangle 13"/>
+          <p:cNvPr id="15" name="Rounded Rectangle 14"/>
           <p:cNvSpPr/>
           <p:nvPr/>
         </p:nvSpPr>
@@ -8909,7 +8987,7 @@
       </p:sp>
       <p:sp>
         <p:nvSpPr>
-          <p:cNvPr id="15" name="Rectangle 14"/>
+          <p:cNvPr id="16" name="Rectangle 15"/>
           <p:cNvSpPr/>
           <p:nvPr/>
         </p:nvSpPr>
@@ -8952,7 +9030,7 @@
       </p:sp>
       <p:sp>
         <p:nvSpPr>
-          <p:cNvPr id="16" name="Oval 15"/>
+          <p:cNvPr id="17" name="Oval 16"/>
           <p:cNvSpPr/>
           <p:nvPr/>
         </p:nvSpPr>
@@ -8997,7 +9075,7 @@
       </p:sp>
       <p:sp>
         <p:nvSpPr>
-          <p:cNvPr id="17" name="TextBox 16"/>
+          <p:cNvPr id="18" name="TextBox 17"/>
           <p:cNvSpPr txBox="1"/>
           <p:nvPr/>
         </p:nvSpPr>
@@ -9033,7 +9111,7 @@
       </p:sp>
       <p:sp>
         <p:nvSpPr>
-          <p:cNvPr id="18" name="TextBox 17"/>
+          <p:cNvPr id="19" name="TextBox 18"/>
           <p:cNvSpPr txBox="1"/>
           <p:nvPr/>
         </p:nvSpPr>
@@ -9054,7 +9132,7 @@
           <a:lstStyle/>
           <a:p>
             <a:pPr algn="l">
-              <a:defRPr sz="1600" b="1" i="0">
+              <a:defRPr sz="1800" b="1" i="0">
                 <a:solidFill>
                   <a:srgbClr val="A9C0DE"/>
                 </a:solidFill>
@@ -9069,7 +9147,7 @@
       </p:sp>
       <p:sp>
         <p:nvSpPr>
-          <p:cNvPr id="19" name="TextBox 18"/>
+          <p:cNvPr id="20" name="TextBox 19"/>
           <p:cNvSpPr txBox="1"/>
           <p:nvPr/>
         </p:nvSpPr>
@@ -9090,7 +9168,7 @@
           <a:lstStyle/>
           <a:p>
             <a:pPr algn="l">
-              <a:defRPr sz="1200" b="0" i="0">
+              <a:defRPr sz="1400" b="0" i="0">
                 <a:solidFill>
                   <a:srgbClr val="D3DFE8"/>
                 </a:solidFill>
@@ -9105,7 +9183,7 @@
       </p:sp>
       <p:sp>
         <p:nvSpPr>
-          <p:cNvPr id="20" name="Rounded Rectangle 19"/>
+          <p:cNvPr id="21" name="Rounded Rectangle 20"/>
           <p:cNvSpPr/>
           <p:nvPr/>
         </p:nvSpPr>
@@ -9150,7 +9228,7 @@
       </p:sp>
       <p:sp>
         <p:nvSpPr>
-          <p:cNvPr id="21" name="Rectangle 20"/>
+          <p:cNvPr id="22" name="Rectangle 21"/>
           <p:cNvSpPr/>
           <p:nvPr/>
         </p:nvSpPr>
@@ -9193,7 +9271,7 @@
       </p:sp>
       <p:sp>
         <p:nvSpPr>
-          <p:cNvPr id="22" name="Oval 21"/>
+          <p:cNvPr id="23" name="Oval 22"/>
           <p:cNvSpPr/>
           <p:nvPr/>
         </p:nvSpPr>
@@ -9238,7 +9316,7 @@
       </p:sp>
       <p:sp>
         <p:nvSpPr>
-          <p:cNvPr id="23" name="TextBox 22"/>
+          <p:cNvPr id="24" name="TextBox 23"/>
           <p:cNvSpPr txBox="1"/>
           <p:nvPr/>
         </p:nvSpPr>
@@ -9274,7 +9352,7 @@
       </p:sp>
       <p:sp>
         <p:nvSpPr>
-          <p:cNvPr id="24" name="TextBox 23"/>
+          <p:cNvPr id="25" name="TextBox 24"/>
           <p:cNvSpPr txBox="1"/>
           <p:nvPr/>
         </p:nvSpPr>
@@ -9295,7 +9373,7 @@
           <a:lstStyle/>
           <a:p>
             <a:pPr algn="l">
-              <a:defRPr sz="1600" b="1" i="0">
+              <a:defRPr sz="1800" b="1" i="0">
                 <a:solidFill>
                   <a:srgbClr val="A9C0DE"/>
                 </a:solidFill>
@@ -9310,7 +9388,7 @@
       </p:sp>
       <p:sp>
         <p:nvSpPr>
-          <p:cNvPr id="25" name="TextBox 24"/>
+          <p:cNvPr id="26" name="TextBox 25"/>
           <p:cNvSpPr txBox="1"/>
           <p:nvPr/>
         </p:nvSpPr>
@@ -9331,7 +9409,7 @@
           <a:lstStyle/>
           <a:p>
             <a:pPr algn="l">
-              <a:defRPr sz="1200" b="0" i="0">
+              <a:defRPr sz="1400" b="0" i="0">
                 <a:solidFill>
                   <a:srgbClr val="D3DFE8"/>
                 </a:solidFill>
@@ -9346,7 +9424,7 @@
       </p:sp>
       <p:sp>
         <p:nvSpPr>
-          <p:cNvPr id="26" name="TextBox 25"/>
+          <p:cNvPr id="27" name="TextBox 26"/>
           <p:cNvSpPr txBox="1"/>
           <p:nvPr/>
         </p:nvSpPr>
@@ -9382,7 +9460,7 @@
       </p:sp>
       <p:sp>
         <p:nvSpPr>
-          <p:cNvPr id="27" name="Rectangle 26"/>
+          <p:cNvPr id="28" name="Rectangle 27"/>
           <p:cNvSpPr/>
           <p:nvPr/>
         </p:nvSpPr>
@@ -9425,7 +9503,7 @@
       </p:sp>
       <p:sp>
         <p:nvSpPr>
-          <p:cNvPr id="28" name="Rounded Rectangle 27"/>
+          <p:cNvPr id="29" name="Rounded Rectangle 28"/>
           <p:cNvSpPr/>
           <p:nvPr/>
         </p:nvSpPr>
@@ -9470,7 +9548,7 @@
       </p:sp>
       <p:sp>
         <p:nvSpPr>
-          <p:cNvPr id="29" name="Oval 28"/>
+          <p:cNvPr id="30" name="Oval 29"/>
           <p:cNvSpPr/>
           <p:nvPr/>
         </p:nvSpPr>
@@ -9515,7 +9593,7 @@
       </p:sp>
       <p:sp>
         <p:nvSpPr>
-          <p:cNvPr id="30" name="Oval 29"/>
+          <p:cNvPr id="31" name="Oval 30"/>
           <p:cNvSpPr/>
           <p:nvPr/>
         </p:nvSpPr>
@@ -9558,7 +9636,7 @@
       </p:sp>
       <p:sp>
         <p:nvSpPr>
-          <p:cNvPr id="31" name="TextBox 30"/>
+          <p:cNvPr id="32" name="TextBox 31"/>
           <p:cNvSpPr txBox="1"/>
           <p:nvPr/>
         </p:nvSpPr>
@@ -9594,7 +9672,7 @@
       </p:sp>
       <p:sp>
         <p:nvSpPr>
-          <p:cNvPr id="32" name="TextBox 31"/>
+          <p:cNvPr id="33" name="TextBox 32"/>
           <p:cNvSpPr txBox="1"/>
           <p:nvPr/>
         </p:nvSpPr>
@@ -9634,7 +9712,7 @@
       </p:sp>
       <p:sp>
         <p:nvSpPr>
-          <p:cNvPr id="33" name="Rounded Rectangle 32"/>
+          <p:cNvPr id="34" name="Rounded Rectangle 33"/>
           <p:cNvSpPr/>
           <p:nvPr/>
         </p:nvSpPr>
@@ -9679,7 +9757,7 @@
       </p:sp>
       <p:sp>
         <p:nvSpPr>
-          <p:cNvPr id="34" name="Oval 33"/>
+          <p:cNvPr id="35" name="Oval 34"/>
           <p:cNvSpPr/>
           <p:nvPr/>
         </p:nvSpPr>
@@ -9724,7 +9802,7 @@
       </p:sp>
       <p:sp>
         <p:nvSpPr>
-          <p:cNvPr id="35" name="Oval 34"/>
+          <p:cNvPr id="36" name="Oval 35"/>
           <p:cNvSpPr/>
           <p:nvPr/>
         </p:nvSpPr>
@@ -9767,7 +9845,7 @@
       </p:sp>
       <p:sp>
         <p:nvSpPr>
-          <p:cNvPr id="36" name="TextBox 35"/>
+          <p:cNvPr id="37" name="TextBox 36"/>
           <p:cNvSpPr txBox="1"/>
           <p:nvPr/>
         </p:nvSpPr>
@@ -9803,7 +9881,7 @@
       </p:sp>
       <p:sp>
         <p:nvSpPr>
-          <p:cNvPr id="37" name="TextBox 36"/>
+          <p:cNvPr id="38" name="TextBox 37"/>
           <p:cNvSpPr txBox="1"/>
           <p:nvPr/>
         </p:nvSpPr>
@@ -9843,7 +9921,7 @@
       </p:sp>
       <p:sp>
         <p:nvSpPr>
-          <p:cNvPr id="38" name="Rounded Rectangle 37"/>
+          <p:cNvPr id="39" name="Rounded Rectangle 38"/>
           <p:cNvSpPr/>
           <p:nvPr/>
         </p:nvSpPr>
@@ -9888,7 +9966,7 @@
       </p:sp>
       <p:sp>
         <p:nvSpPr>
-          <p:cNvPr id="39" name="Oval 38"/>
+          <p:cNvPr id="40" name="Oval 39"/>
           <p:cNvSpPr/>
           <p:nvPr/>
         </p:nvSpPr>
@@ -9933,7 +10011,7 @@
       </p:sp>
       <p:sp>
         <p:nvSpPr>
-          <p:cNvPr id="40" name="Oval 39"/>
+          <p:cNvPr id="41" name="Oval 40"/>
           <p:cNvSpPr/>
           <p:nvPr/>
         </p:nvSpPr>
@@ -9976,7 +10054,7 @@
       </p:sp>
       <p:sp>
         <p:nvSpPr>
-          <p:cNvPr id="41" name="TextBox 40"/>
+          <p:cNvPr id="42" name="TextBox 41"/>
           <p:cNvSpPr txBox="1"/>
           <p:nvPr/>
         </p:nvSpPr>
@@ -10012,7 +10090,7 @@
       </p:sp>
       <p:sp>
         <p:nvSpPr>
-          <p:cNvPr id="42" name="TextBox 41"/>
+          <p:cNvPr id="43" name="TextBox 42"/>
           <p:cNvSpPr txBox="1"/>
           <p:nvPr/>
         </p:nvSpPr>
@@ -10052,7 +10130,7 @@
       </p:sp>
       <p:sp>
         <p:nvSpPr>
-          <p:cNvPr id="43" name="Rounded Rectangle 42"/>
+          <p:cNvPr id="44" name="Rounded Rectangle 43"/>
           <p:cNvSpPr/>
           <p:nvPr/>
         </p:nvSpPr>
@@ -10097,7 +10175,7 @@
       </p:sp>
       <p:sp>
         <p:nvSpPr>
-          <p:cNvPr id="44" name="Oval 43"/>
+          <p:cNvPr id="45" name="Oval 44"/>
           <p:cNvSpPr/>
           <p:nvPr/>
         </p:nvSpPr>
@@ -10142,7 +10220,7 @@
       </p:sp>
       <p:sp>
         <p:nvSpPr>
-          <p:cNvPr id="45" name="Oval 44"/>
+          <p:cNvPr id="46" name="Oval 45"/>
           <p:cNvSpPr/>
           <p:nvPr/>
         </p:nvSpPr>
@@ -10185,7 +10263,7 @@
       </p:sp>
       <p:sp>
         <p:nvSpPr>
-          <p:cNvPr id="46" name="TextBox 45"/>
+          <p:cNvPr id="47" name="TextBox 46"/>
           <p:cNvSpPr txBox="1"/>
           <p:nvPr/>
         </p:nvSpPr>
@@ -10221,7 +10299,7 @@
       </p:sp>
       <p:sp>
         <p:nvSpPr>
-          <p:cNvPr id="47" name="TextBox 46"/>
+          <p:cNvPr id="48" name="TextBox 47"/>
           <p:cNvSpPr txBox="1"/>
           <p:nvPr/>
         </p:nvSpPr>
@@ -10261,7 +10339,7 @@
       </p:sp>
       <p:sp>
         <p:nvSpPr>
-          <p:cNvPr id="48" name="Rectangle 47"/>
+          <p:cNvPr id="49" name="Rectangle 48"/>
           <p:cNvSpPr/>
           <p:nvPr/>
         </p:nvSpPr>
@@ -10304,7 +10382,7 @@
       </p:sp>
       <p:sp>
         <p:nvSpPr>
-          <p:cNvPr id="49" name="TextBox 48"/>
+          <p:cNvPr id="50" name="TextBox 49"/>
           <p:cNvSpPr txBox="1"/>
           <p:nvPr/>
         </p:nvSpPr>
@@ -10340,7 +10418,7 @@
       </p:sp>
       <p:pic>
         <p:nvPicPr>
-          <p:cNvPr id="50" name="Picture 49" descr="logo-wolf.png"/>
+          <p:cNvPr id="51" name="Picture 50" descr="logo-wolf.png"/>
           <p:cNvPicPr>
             <a:picLocks noChangeAspect="1"/>
           </p:cNvPicPr>
@@ -10388,9 +10466,35 @@
         <p:nvPr/>
       </p:nvGrpSpPr>
       <p:grpSpPr/>
-      <p:sp>
-        <p:nvSpPr>
-          <p:cNvPr id="2" name="Rectangle 1"/>
+      <p:pic>
+        <p:nvPicPr>
+          <p:cNvPr id="2" name="Picture 1" descr="logo-wolf.png"/>
+          <p:cNvPicPr>
+            <a:picLocks noChangeAspect="1"/>
+          </p:cNvPicPr>
+          <p:nvPr/>
+        </p:nvPicPr>
+        <p:blipFill>
+          <a:blip r:embed="rId2">
+            <a:alphaModFix amt="8000"/>
+          </a:blip>
+          <a:stretch>
+            <a:fillRect/>
+          </a:stretch>
+        </p:blipFill>
+        <p:spPr>
+          <a:xfrm>
+            <a:off x="3840480" y="1371600"/>
+            <a:ext cx="4572000" cy="4572000"/>
+          </a:xfrm>
+          <a:prstGeom prst="rect">
+            <a:avLst/>
+          </a:prstGeom>
+        </p:spPr>
+      </p:pic>
+      <p:sp>
+        <p:nvSpPr>
+          <p:cNvPr id="3" name="Rectangle 2"/>
           <p:cNvSpPr/>
           <p:nvPr/>
         </p:nvSpPr>
@@ -10435,7 +10539,7 @@
       </p:sp>
       <p:sp>
         <p:nvSpPr>
-          <p:cNvPr id="3" name="Rectangle 2"/>
+          <p:cNvPr id="4" name="Rectangle 3"/>
           <p:cNvSpPr/>
           <p:nvPr/>
         </p:nvSpPr>
@@ -10480,7 +10584,7 @@
       </p:sp>
       <p:sp>
         <p:nvSpPr>
-          <p:cNvPr id="4" name="Rectangle 3"/>
+          <p:cNvPr id="5" name="Rectangle 4"/>
           <p:cNvSpPr/>
           <p:nvPr/>
         </p:nvSpPr>
@@ -10525,7 +10629,7 @@
       </p:sp>
       <p:sp>
         <p:nvSpPr>
-          <p:cNvPr id="5" name="Rectangle 4"/>
+          <p:cNvPr id="6" name="Rectangle 5"/>
           <p:cNvSpPr/>
           <p:nvPr/>
         </p:nvSpPr>
@@ -10568,7 +10672,7 @@
       </p:sp>
       <p:sp>
         <p:nvSpPr>
-          <p:cNvPr id="6" name="Oval 5"/>
+          <p:cNvPr id="7" name="Oval 6"/>
           <p:cNvSpPr/>
           <p:nvPr/>
         </p:nvSpPr>
@@ -10613,7 +10717,7 @@
       </p:sp>
       <p:sp>
         <p:nvSpPr>
-          <p:cNvPr id="7" name="Oval 6"/>
+          <p:cNvPr id="8" name="Oval 7"/>
           <p:cNvSpPr/>
           <p:nvPr/>
         </p:nvSpPr>
@@ -10658,7 +10762,7 @@
       </p:sp>
       <p:sp>
         <p:nvSpPr>
-          <p:cNvPr id="8" name="Oval 7"/>
+          <p:cNvPr id="9" name="Oval 8"/>
           <p:cNvSpPr/>
           <p:nvPr/>
         </p:nvSpPr>
@@ -10703,7 +10807,7 @@
       </p:sp>
       <p:sp>
         <p:nvSpPr>
-          <p:cNvPr id="9" name="Oval 8"/>
+          <p:cNvPr id="10" name="Oval 9"/>
           <p:cNvSpPr/>
           <p:nvPr/>
         </p:nvSpPr>
@@ -10748,7 +10852,7 @@
       </p:sp>
       <p:sp>
         <p:nvSpPr>
-          <p:cNvPr id="10" name="Rectangle 9"/>
+          <p:cNvPr id="11" name="Rectangle 10"/>
           <p:cNvSpPr/>
           <p:nvPr/>
         </p:nvSpPr>
@@ -10791,7 +10895,7 @@
       </p:sp>
       <p:sp>
         <p:nvSpPr>
-          <p:cNvPr id="11" name="TextBox 10"/>
+          <p:cNvPr id="12" name="TextBox 11"/>
           <p:cNvSpPr txBox="1"/>
           <p:nvPr/>
         </p:nvSpPr>
@@ -10827,7 +10931,7 @@
       </p:sp>
       <p:sp>
         <p:nvSpPr>
-          <p:cNvPr id="12" name="TextBox 11"/>
+          <p:cNvPr id="13" name="TextBox 12"/>
           <p:cNvSpPr txBox="1"/>
           <p:nvPr/>
         </p:nvSpPr>
@@ -10863,7 +10967,7 @@
       </p:sp>
       <p:sp>
         <p:nvSpPr>
-          <p:cNvPr id="13" name="TextBox 12"/>
+          <p:cNvPr id="14" name="TextBox 13"/>
           <p:cNvSpPr txBox="1"/>
           <p:nvPr/>
         </p:nvSpPr>
@@ -10899,7 +11003,7 @@
       </p:sp>
       <p:sp>
         <p:nvSpPr>
-          <p:cNvPr id="14" name="Rectangle 13"/>
+          <p:cNvPr id="15" name="Rectangle 14"/>
           <p:cNvSpPr/>
           <p:nvPr/>
         </p:nvSpPr>
@@ -10942,7 +11046,7 @@
       </p:sp>
       <p:sp>
         <p:nvSpPr>
-          <p:cNvPr id="15" name="Rounded Rectangle 14"/>
+          <p:cNvPr id="16" name="Rounded Rectangle 15"/>
           <p:cNvSpPr/>
           <p:nvPr/>
         </p:nvSpPr>
@@ -10987,7 +11091,7 @@
       </p:sp>
       <p:sp>
         <p:nvSpPr>
-          <p:cNvPr id="16" name="Rectangle 15"/>
+          <p:cNvPr id="17" name="Rectangle 16"/>
           <p:cNvSpPr/>
           <p:nvPr/>
         </p:nvSpPr>
@@ -11030,7 +11134,7 @@
       </p:sp>
       <p:sp>
         <p:nvSpPr>
-          <p:cNvPr id="17" name="Rounded Rectangle 16"/>
+          <p:cNvPr id="18" name="Rounded Rectangle 17"/>
           <p:cNvSpPr/>
           <p:nvPr/>
         </p:nvSpPr>
@@ -11075,7 +11179,7 @@
       </p:sp>
       <p:sp>
         <p:nvSpPr>
-          <p:cNvPr id="18" name="TextBox 17"/>
+          <p:cNvPr id="19" name="TextBox 18"/>
           <p:cNvSpPr txBox="1"/>
           <p:nvPr/>
         </p:nvSpPr>
@@ -11111,7 +11215,7 @@
       </p:sp>
       <p:sp>
         <p:nvSpPr>
-          <p:cNvPr id="19" name="TextBox 18"/>
+          <p:cNvPr id="20" name="TextBox 19"/>
           <p:cNvSpPr txBox="1"/>
           <p:nvPr/>
         </p:nvSpPr>
@@ -11132,7 +11236,7 @@
           <a:lstStyle/>
           <a:p>
             <a:pPr algn="l">
-              <a:defRPr sz="1600" b="1" i="0">
+              <a:defRPr sz="1800" b="1" i="0">
                 <a:solidFill>
                   <a:srgbClr val="FFFFFF"/>
                 </a:solidFill>
@@ -11147,7 +11251,7 @@
       </p:sp>
       <p:sp>
         <p:nvSpPr>
-          <p:cNvPr id="20" name="Rectangle 19"/>
+          <p:cNvPr id="21" name="Rectangle 20"/>
           <p:cNvSpPr/>
           <p:nvPr/>
         </p:nvSpPr>
@@ -11190,7 +11294,7 @@
       </p:sp>
       <p:sp>
         <p:nvSpPr>
-          <p:cNvPr id="21" name="TextBox 20"/>
+          <p:cNvPr id="22" name="TextBox 21"/>
           <p:cNvSpPr txBox="1"/>
           <p:nvPr/>
         </p:nvSpPr>
@@ -11211,7 +11315,7 @@
           <a:lstStyle/>
           <a:p>
             <a:pPr algn="l">
-              <a:defRPr sz="1100" b="0" i="0">
+              <a:defRPr sz="1300" b="0" i="0">
                 <a:solidFill>
                   <a:srgbClr val="D3DFE8"/>
                 </a:solidFill>
@@ -11226,7 +11330,7 @@
       </p:sp>
       <p:sp>
         <p:nvSpPr>
-          <p:cNvPr id="22" name="Oval 21"/>
+          <p:cNvPr id="23" name="Oval 22"/>
           <p:cNvSpPr/>
           <p:nvPr/>
         </p:nvSpPr>
@@ -11271,7 +11375,7 @@
       </p:sp>
       <p:sp>
         <p:nvSpPr>
-          <p:cNvPr id="23" name="Rounded Rectangle 22"/>
+          <p:cNvPr id="24" name="Rounded Rectangle 23"/>
           <p:cNvSpPr/>
           <p:nvPr/>
         </p:nvSpPr>
@@ -11316,7 +11420,7 @@
       </p:sp>
       <p:sp>
         <p:nvSpPr>
-          <p:cNvPr id="24" name="Rectangle 23"/>
+          <p:cNvPr id="25" name="Rectangle 24"/>
           <p:cNvSpPr/>
           <p:nvPr/>
         </p:nvSpPr>
@@ -11359,7 +11463,7 @@
       </p:sp>
       <p:sp>
         <p:nvSpPr>
-          <p:cNvPr id="25" name="Rounded Rectangle 24"/>
+          <p:cNvPr id="26" name="Rounded Rectangle 25"/>
           <p:cNvSpPr/>
           <p:nvPr/>
         </p:nvSpPr>
@@ -11404,7 +11508,7 @@
       </p:sp>
       <p:sp>
         <p:nvSpPr>
-          <p:cNvPr id="26" name="TextBox 25"/>
+          <p:cNvPr id="27" name="TextBox 26"/>
           <p:cNvSpPr txBox="1"/>
           <p:nvPr/>
         </p:nvSpPr>
@@ -11440,7 +11544,7 @@
       </p:sp>
       <p:sp>
         <p:nvSpPr>
-          <p:cNvPr id="27" name="TextBox 26"/>
+          <p:cNvPr id="28" name="TextBox 27"/>
           <p:cNvSpPr txBox="1"/>
           <p:nvPr/>
         </p:nvSpPr>
@@ -11461,7 +11565,7 @@
           <a:lstStyle/>
           <a:p>
             <a:pPr algn="l">
-              <a:defRPr sz="1600" b="1" i="0">
+              <a:defRPr sz="1800" b="1" i="0">
                 <a:solidFill>
                   <a:srgbClr val="FFFFFF"/>
                 </a:solidFill>
@@ -11476,7 +11580,7 @@
       </p:sp>
       <p:sp>
         <p:nvSpPr>
-          <p:cNvPr id="28" name="Rectangle 27"/>
+          <p:cNvPr id="29" name="Rectangle 28"/>
           <p:cNvSpPr/>
           <p:nvPr/>
         </p:nvSpPr>
@@ -11519,7 +11623,7 @@
       </p:sp>
       <p:sp>
         <p:nvSpPr>
-          <p:cNvPr id="29" name="TextBox 28"/>
+          <p:cNvPr id="30" name="TextBox 29"/>
           <p:cNvSpPr txBox="1"/>
           <p:nvPr/>
         </p:nvSpPr>
@@ -11540,7 +11644,7 @@
           <a:lstStyle/>
           <a:p>
             <a:pPr algn="l">
-              <a:defRPr sz="1100" b="0" i="0">
+              <a:defRPr sz="1300" b="0" i="0">
                 <a:solidFill>
                   <a:srgbClr val="D3DFE8"/>
                 </a:solidFill>
@@ -11555,7 +11659,7 @@
       </p:sp>
       <p:sp>
         <p:nvSpPr>
-          <p:cNvPr id="30" name="Oval 29"/>
+          <p:cNvPr id="31" name="Oval 30"/>
           <p:cNvSpPr/>
           <p:nvPr/>
         </p:nvSpPr>
@@ -11600,7 +11704,7 @@
       </p:sp>
       <p:sp>
         <p:nvSpPr>
-          <p:cNvPr id="31" name="Rounded Rectangle 30"/>
+          <p:cNvPr id="32" name="Rounded Rectangle 31"/>
           <p:cNvSpPr/>
           <p:nvPr/>
         </p:nvSpPr>
@@ -11645,7 +11749,7 @@
       </p:sp>
       <p:sp>
         <p:nvSpPr>
-          <p:cNvPr id="32" name="Rectangle 31"/>
+          <p:cNvPr id="33" name="Rectangle 32"/>
           <p:cNvSpPr/>
           <p:nvPr/>
         </p:nvSpPr>
@@ -11688,7 +11792,7 @@
       </p:sp>
       <p:sp>
         <p:nvSpPr>
-          <p:cNvPr id="33" name="Rounded Rectangle 32"/>
+          <p:cNvPr id="34" name="Rounded Rectangle 33"/>
           <p:cNvSpPr/>
           <p:nvPr/>
         </p:nvSpPr>
@@ -11733,7 +11837,7 @@
       </p:sp>
       <p:sp>
         <p:nvSpPr>
-          <p:cNvPr id="34" name="TextBox 33"/>
+          <p:cNvPr id="35" name="TextBox 34"/>
           <p:cNvSpPr txBox="1"/>
           <p:nvPr/>
         </p:nvSpPr>
@@ -11769,7 +11873,7 @@
       </p:sp>
       <p:sp>
         <p:nvSpPr>
-          <p:cNvPr id="35" name="TextBox 34"/>
+          <p:cNvPr id="36" name="TextBox 35"/>
           <p:cNvSpPr txBox="1"/>
           <p:nvPr/>
         </p:nvSpPr>
@@ -11790,7 +11894,7 @@
           <a:lstStyle/>
           <a:p>
             <a:pPr algn="l">
-              <a:defRPr sz="1600" b="1" i="0">
+              <a:defRPr sz="1800" b="1" i="0">
                 <a:solidFill>
                   <a:srgbClr val="FFFFFF"/>
                 </a:solidFill>
@@ -11805,7 +11909,7 @@
       </p:sp>
       <p:sp>
         <p:nvSpPr>
-          <p:cNvPr id="36" name="Rectangle 35"/>
+          <p:cNvPr id="37" name="Rectangle 36"/>
           <p:cNvSpPr/>
           <p:nvPr/>
         </p:nvSpPr>
@@ -11848,7 +11952,7 @@
       </p:sp>
       <p:sp>
         <p:nvSpPr>
-          <p:cNvPr id="37" name="TextBox 36"/>
+          <p:cNvPr id="38" name="TextBox 37"/>
           <p:cNvSpPr txBox="1"/>
           <p:nvPr/>
         </p:nvSpPr>
@@ -11869,7 +11973,7 @@
           <a:lstStyle/>
           <a:p>
             <a:pPr algn="l">
-              <a:defRPr sz="1100" b="0" i="0">
+              <a:defRPr sz="1300" b="0" i="0">
                 <a:solidFill>
                   <a:srgbClr val="D3DFE8"/>
                 </a:solidFill>
@@ -11884,7 +11988,7 @@
       </p:sp>
       <p:sp>
         <p:nvSpPr>
-          <p:cNvPr id="38" name="Oval 37"/>
+          <p:cNvPr id="39" name="Oval 38"/>
           <p:cNvSpPr/>
           <p:nvPr/>
         </p:nvSpPr>
@@ -11929,7 +12033,7 @@
       </p:sp>
       <p:sp>
         <p:nvSpPr>
-          <p:cNvPr id="39" name="TextBox 38"/>
+          <p:cNvPr id="40" name="TextBox 39"/>
           <p:cNvSpPr txBox="1"/>
           <p:nvPr/>
         </p:nvSpPr>
@@ -11965,7 +12069,7 @@
       </p:sp>
       <p:sp>
         <p:nvSpPr>
-          <p:cNvPr id="40" name="Rectangle 39"/>
+          <p:cNvPr id="41" name="Rectangle 40"/>
           <p:cNvSpPr/>
           <p:nvPr/>
         </p:nvSpPr>
@@ -12008,7 +12112,7 @@
       </p:sp>
       <p:sp>
         <p:nvSpPr>
-          <p:cNvPr id="41" name="Rounded Rectangle 40"/>
+          <p:cNvPr id="42" name="Rounded Rectangle 41"/>
           <p:cNvSpPr/>
           <p:nvPr/>
         </p:nvSpPr>
@@ -12053,7 +12157,7 @@
       </p:sp>
       <p:sp>
         <p:nvSpPr>
-          <p:cNvPr id="42" name="Rectangle 41"/>
+          <p:cNvPr id="43" name="Rectangle 42"/>
           <p:cNvSpPr/>
           <p:nvPr/>
         </p:nvSpPr>
@@ -12096,7 +12200,7 @@
       </p:sp>
       <p:sp>
         <p:nvSpPr>
-          <p:cNvPr id="43" name="TextBox 42"/>
+          <p:cNvPr id="44" name="TextBox 43"/>
           <p:cNvSpPr txBox="1"/>
           <p:nvPr/>
         </p:nvSpPr>
@@ -12136,7 +12240,7 @@
       </p:sp>
       <p:sp>
         <p:nvSpPr>
-          <p:cNvPr id="44" name="Rounded Rectangle 43"/>
+          <p:cNvPr id="45" name="Rounded Rectangle 44"/>
           <p:cNvSpPr/>
           <p:nvPr/>
         </p:nvSpPr>
@@ -12181,7 +12285,7 @@
       </p:sp>
       <p:sp>
         <p:nvSpPr>
-          <p:cNvPr id="45" name="TextBox 44"/>
+          <p:cNvPr id="46" name="TextBox 45"/>
           <p:cNvSpPr txBox="1"/>
           <p:nvPr/>
         </p:nvSpPr>
@@ -12217,7 +12321,7 @@
       </p:sp>
       <p:sp>
         <p:nvSpPr>
-          <p:cNvPr id="46" name="Rounded Rectangle 45"/>
+          <p:cNvPr id="47" name="Rounded Rectangle 46"/>
           <p:cNvSpPr/>
           <p:nvPr/>
         </p:nvSpPr>
@@ -12262,7 +12366,7 @@
       </p:sp>
       <p:sp>
         <p:nvSpPr>
-          <p:cNvPr id="47" name="Rectangle 46"/>
+          <p:cNvPr id="48" name="Rectangle 47"/>
           <p:cNvSpPr/>
           <p:nvPr/>
         </p:nvSpPr>
@@ -12305,7 +12409,7 @@
       </p:sp>
       <p:sp>
         <p:nvSpPr>
-          <p:cNvPr id="48" name="TextBox 47"/>
+          <p:cNvPr id="49" name="TextBox 48"/>
           <p:cNvSpPr txBox="1"/>
           <p:nvPr/>
         </p:nvSpPr>
@@ -12345,7 +12449,7 @@
       </p:sp>
       <p:sp>
         <p:nvSpPr>
-          <p:cNvPr id="49" name="Rounded Rectangle 48"/>
+          <p:cNvPr id="50" name="Rounded Rectangle 49"/>
           <p:cNvSpPr/>
           <p:nvPr/>
         </p:nvSpPr>
@@ -12390,7 +12494,7 @@
       </p:sp>
       <p:sp>
         <p:nvSpPr>
-          <p:cNvPr id="50" name="TextBox 49"/>
+          <p:cNvPr id="51" name="TextBox 50"/>
           <p:cNvSpPr txBox="1"/>
           <p:nvPr/>
         </p:nvSpPr>
@@ -12426,7 +12530,7 @@
       </p:sp>
       <p:sp>
         <p:nvSpPr>
-          <p:cNvPr id="51" name="Rounded Rectangle 50"/>
+          <p:cNvPr id="52" name="Rounded Rectangle 51"/>
           <p:cNvSpPr/>
           <p:nvPr/>
         </p:nvSpPr>
@@ -12471,7 +12575,7 @@
       </p:sp>
       <p:sp>
         <p:nvSpPr>
-          <p:cNvPr id="52" name="Rectangle 51"/>
+          <p:cNvPr id="53" name="Rectangle 52"/>
           <p:cNvSpPr/>
           <p:nvPr/>
         </p:nvSpPr>
@@ -12514,7 +12618,7 @@
       </p:sp>
       <p:sp>
         <p:nvSpPr>
-          <p:cNvPr id="53" name="TextBox 52"/>
+          <p:cNvPr id="54" name="TextBox 53"/>
           <p:cNvSpPr txBox="1"/>
           <p:nvPr/>
         </p:nvSpPr>
@@ -12554,7 +12658,7 @@
       </p:sp>
       <p:sp>
         <p:nvSpPr>
-          <p:cNvPr id="54" name="Rounded Rectangle 53"/>
+          <p:cNvPr id="55" name="Rounded Rectangle 54"/>
           <p:cNvSpPr/>
           <p:nvPr/>
         </p:nvSpPr>
@@ -12599,7 +12703,7 @@
       </p:sp>
       <p:sp>
         <p:nvSpPr>
-          <p:cNvPr id="55" name="TextBox 54"/>
+          <p:cNvPr id="56" name="TextBox 55"/>
           <p:cNvSpPr txBox="1"/>
           <p:nvPr/>
         </p:nvSpPr>
@@ -12635,7 +12739,7 @@
       </p:sp>
       <p:sp>
         <p:nvSpPr>
-          <p:cNvPr id="56" name="Rounded Rectangle 55"/>
+          <p:cNvPr id="57" name="Rounded Rectangle 56"/>
           <p:cNvSpPr/>
           <p:nvPr/>
         </p:nvSpPr>
@@ -12680,7 +12784,7 @@
       </p:sp>
       <p:sp>
         <p:nvSpPr>
-          <p:cNvPr id="57" name="Rectangle 56"/>
+          <p:cNvPr id="58" name="Rectangle 57"/>
           <p:cNvSpPr/>
           <p:nvPr/>
         </p:nvSpPr>
@@ -12723,7 +12827,7 @@
       </p:sp>
       <p:sp>
         <p:nvSpPr>
-          <p:cNvPr id="58" name="TextBox 57"/>
+          <p:cNvPr id="59" name="TextBox 58"/>
           <p:cNvSpPr txBox="1"/>
           <p:nvPr/>
         </p:nvSpPr>
@@ -12763,7 +12867,7 @@
       </p:sp>
       <p:sp>
         <p:nvSpPr>
-          <p:cNvPr id="59" name="Rounded Rectangle 58"/>
+          <p:cNvPr id="60" name="Rounded Rectangle 59"/>
           <p:cNvSpPr/>
           <p:nvPr/>
         </p:nvSpPr>
@@ -12808,7 +12912,7 @@
       </p:sp>
       <p:sp>
         <p:nvSpPr>
-          <p:cNvPr id="60" name="TextBox 59"/>
+          <p:cNvPr id="61" name="TextBox 60"/>
           <p:cNvSpPr txBox="1"/>
           <p:nvPr/>
         </p:nvSpPr>
@@ -12844,7 +12948,7 @@
       </p:sp>
       <p:sp>
         <p:nvSpPr>
-          <p:cNvPr id="61" name="Rounded Rectangle 60"/>
+          <p:cNvPr id="62" name="Rounded Rectangle 61"/>
           <p:cNvSpPr/>
           <p:nvPr/>
         </p:nvSpPr>
@@ -12889,7 +12993,7 @@
       </p:sp>
       <p:sp>
         <p:nvSpPr>
-          <p:cNvPr id="62" name="Rectangle 61"/>
+          <p:cNvPr id="63" name="Rectangle 62"/>
           <p:cNvSpPr/>
           <p:nvPr/>
         </p:nvSpPr>
@@ -12932,7 +13036,7 @@
       </p:sp>
       <p:sp>
         <p:nvSpPr>
-          <p:cNvPr id="63" name="TextBox 62"/>
+          <p:cNvPr id="64" name="TextBox 63"/>
           <p:cNvSpPr txBox="1"/>
           <p:nvPr/>
         </p:nvSpPr>
@@ -12972,7 +13076,7 @@
       </p:sp>
       <p:sp>
         <p:nvSpPr>
-          <p:cNvPr id="64" name="Rounded Rectangle 63"/>
+          <p:cNvPr id="65" name="Rounded Rectangle 64"/>
           <p:cNvSpPr/>
           <p:nvPr/>
         </p:nvSpPr>
@@ -13017,7 +13121,7 @@
       </p:sp>
       <p:sp>
         <p:nvSpPr>
-          <p:cNvPr id="65" name="TextBox 64"/>
+          <p:cNvPr id="66" name="TextBox 65"/>
           <p:cNvSpPr txBox="1"/>
           <p:nvPr/>
         </p:nvSpPr>
@@ -13053,7 +13157,7 @@
       </p:sp>
       <p:sp>
         <p:nvSpPr>
-          <p:cNvPr id="66" name="Rounded Rectangle 65"/>
+          <p:cNvPr id="67" name="Rounded Rectangle 66"/>
           <p:cNvSpPr/>
           <p:nvPr/>
         </p:nvSpPr>
@@ -13098,7 +13202,7 @@
       </p:sp>
       <p:sp>
         <p:nvSpPr>
-          <p:cNvPr id="67" name="Rectangle 66"/>
+          <p:cNvPr id="68" name="Rectangle 67"/>
           <p:cNvSpPr/>
           <p:nvPr/>
         </p:nvSpPr>
@@ -13141,7 +13245,7 @@
       </p:sp>
       <p:sp>
         <p:nvSpPr>
-          <p:cNvPr id="68" name="TextBox 67"/>
+          <p:cNvPr id="69" name="TextBox 68"/>
           <p:cNvSpPr txBox="1"/>
           <p:nvPr/>
         </p:nvSpPr>
@@ -13181,7 +13285,7 @@
       </p:sp>
       <p:sp>
         <p:nvSpPr>
-          <p:cNvPr id="69" name="Rounded Rectangle 68"/>
+          <p:cNvPr id="70" name="Rounded Rectangle 69"/>
           <p:cNvSpPr/>
           <p:nvPr/>
         </p:nvSpPr>
@@ -13226,7 +13330,7 @@
       </p:sp>
       <p:sp>
         <p:nvSpPr>
-          <p:cNvPr id="70" name="TextBox 69"/>
+          <p:cNvPr id="71" name="TextBox 70"/>
           <p:cNvSpPr txBox="1"/>
           <p:nvPr/>
         </p:nvSpPr>
@@ -13262,7 +13366,7 @@
       </p:sp>
       <p:sp>
         <p:nvSpPr>
-          <p:cNvPr id="71" name="Rectangle 70"/>
+          <p:cNvPr id="72" name="Rectangle 71"/>
           <p:cNvSpPr/>
           <p:nvPr/>
         </p:nvSpPr>
@@ -13305,7 +13409,7 @@
       </p:sp>
       <p:sp>
         <p:nvSpPr>
-          <p:cNvPr id="72" name="TextBox 71"/>
+          <p:cNvPr id="73" name="TextBox 72"/>
           <p:cNvSpPr txBox="1"/>
           <p:nvPr/>
         </p:nvSpPr>
@@ -13341,7 +13445,7 @@
       </p:sp>
       <p:pic>
         <p:nvPicPr>
-          <p:cNvPr id="73" name="Picture 72" descr="logo-wolf.png"/>
+          <p:cNvPr id="74" name="Picture 73" descr="logo-wolf.png"/>
           <p:cNvPicPr>
             <a:picLocks noChangeAspect="1"/>
           </p:cNvPicPr>
@@ -13389,9 +13493,35 @@
         <p:nvPr/>
       </p:nvGrpSpPr>
       <p:grpSpPr/>
-      <p:sp>
-        <p:nvSpPr>
-          <p:cNvPr id="2" name="Rectangle 1"/>
+      <p:pic>
+        <p:nvPicPr>
+          <p:cNvPr id="2" name="Picture 1" descr="logo-wolf.png"/>
+          <p:cNvPicPr>
+            <a:picLocks noChangeAspect="1"/>
+          </p:cNvPicPr>
+          <p:nvPr/>
+        </p:nvPicPr>
+        <p:blipFill>
+          <a:blip r:embed="rId2">
+            <a:alphaModFix amt="8000"/>
+          </a:blip>
+          <a:stretch>
+            <a:fillRect/>
+          </a:stretch>
+        </p:blipFill>
+        <p:spPr>
+          <a:xfrm>
+            <a:off x="3840480" y="1371600"/>
+            <a:ext cx="4572000" cy="4572000"/>
+          </a:xfrm>
+          <a:prstGeom prst="rect">
+            <a:avLst/>
+          </a:prstGeom>
+        </p:spPr>
+      </p:pic>
+      <p:sp>
+        <p:nvSpPr>
+          <p:cNvPr id="3" name="Rectangle 2"/>
           <p:cNvSpPr/>
           <p:nvPr/>
         </p:nvSpPr>
@@ -13436,7 +13566,7 @@
       </p:sp>
       <p:sp>
         <p:nvSpPr>
-          <p:cNvPr id="3" name="Rectangle 2"/>
+          <p:cNvPr id="4" name="Rectangle 3"/>
           <p:cNvSpPr/>
           <p:nvPr/>
         </p:nvSpPr>
@@ -13481,7 +13611,7 @@
       </p:sp>
       <p:sp>
         <p:nvSpPr>
-          <p:cNvPr id="4" name="Rectangle 3"/>
+          <p:cNvPr id="5" name="Rectangle 4"/>
           <p:cNvSpPr/>
           <p:nvPr/>
         </p:nvSpPr>
@@ -13526,7 +13656,7 @@
       </p:sp>
       <p:sp>
         <p:nvSpPr>
-          <p:cNvPr id="5" name="Rectangle 4"/>
+          <p:cNvPr id="6" name="Rectangle 5"/>
           <p:cNvSpPr/>
           <p:nvPr/>
         </p:nvSpPr>
@@ -13569,7 +13699,7 @@
       </p:sp>
       <p:sp>
         <p:nvSpPr>
-          <p:cNvPr id="6" name="Oval 5"/>
+          <p:cNvPr id="7" name="Oval 6"/>
           <p:cNvSpPr/>
           <p:nvPr/>
         </p:nvSpPr>
@@ -13614,7 +13744,7 @@
       </p:sp>
       <p:sp>
         <p:nvSpPr>
-          <p:cNvPr id="7" name="Oval 6"/>
+          <p:cNvPr id="8" name="Oval 7"/>
           <p:cNvSpPr/>
           <p:nvPr/>
         </p:nvSpPr>
@@ -13659,7 +13789,7 @@
       </p:sp>
       <p:sp>
         <p:nvSpPr>
-          <p:cNvPr id="8" name="Oval 7"/>
+          <p:cNvPr id="9" name="Oval 8"/>
           <p:cNvSpPr/>
           <p:nvPr/>
         </p:nvSpPr>
@@ -13704,7 +13834,7 @@
       </p:sp>
       <p:sp>
         <p:nvSpPr>
-          <p:cNvPr id="9" name="Oval 8"/>
+          <p:cNvPr id="10" name="Oval 9"/>
           <p:cNvSpPr/>
           <p:nvPr/>
         </p:nvSpPr>
@@ -13749,7 +13879,7 @@
       </p:sp>
       <p:sp>
         <p:nvSpPr>
-          <p:cNvPr id="10" name="Rectangle 9"/>
+          <p:cNvPr id="11" name="Rectangle 10"/>
           <p:cNvSpPr/>
           <p:nvPr/>
         </p:nvSpPr>
@@ -13792,7 +13922,7 @@
       </p:sp>
       <p:sp>
         <p:nvSpPr>
-          <p:cNvPr id="11" name="TextBox 10"/>
+          <p:cNvPr id="12" name="TextBox 11"/>
           <p:cNvSpPr txBox="1"/>
           <p:nvPr/>
         </p:nvSpPr>
@@ -13828,7 +13958,7 @@
       </p:sp>
       <p:sp>
         <p:nvSpPr>
-          <p:cNvPr id="12" name="TextBox 11"/>
+          <p:cNvPr id="13" name="TextBox 12"/>
           <p:cNvSpPr txBox="1"/>
           <p:nvPr/>
         </p:nvSpPr>
@@ -13864,7 +13994,7 @@
       </p:sp>
       <p:sp>
         <p:nvSpPr>
-          <p:cNvPr id="13" name="Oval 12"/>
+          <p:cNvPr id="14" name="Oval 13"/>
           <p:cNvSpPr/>
           <p:nvPr/>
         </p:nvSpPr>
@@ -13909,7 +14039,7 @@
       </p:sp>
       <p:sp>
         <p:nvSpPr>
-          <p:cNvPr id="14" name="Oval 13"/>
+          <p:cNvPr id="15" name="Oval 14"/>
           <p:cNvSpPr/>
           <p:nvPr/>
         </p:nvSpPr>
@@ -13954,7 +14084,7 @@
       </p:sp>
       <p:sp>
         <p:nvSpPr>
-          <p:cNvPr id="15" name="Oval 14"/>
+          <p:cNvPr id="16" name="Oval 15"/>
           <p:cNvSpPr/>
           <p:nvPr/>
         </p:nvSpPr>
@@ -13999,7 +14129,7 @@
       </p:sp>
       <p:sp>
         <p:nvSpPr>
-          <p:cNvPr id="16" name="Oval 15"/>
+          <p:cNvPr id="17" name="Oval 16"/>
           <p:cNvSpPr/>
           <p:nvPr/>
         </p:nvSpPr>
@@ -14044,7 +14174,7 @@
       </p:sp>
       <p:sp>
         <p:nvSpPr>
-          <p:cNvPr id="17" name="Oval 16"/>
+          <p:cNvPr id="18" name="Oval 17"/>
           <p:cNvSpPr/>
           <p:nvPr/>
         </p:nvSpPr>
@@ -14089,7 +14219,7 @@
       </p:sp>
       <p:sp>
         <p:nvSpPr>
-          <p:cNvPr id="18" name="Oval 17"/>
+          <p:cNvPr id="19" name="Oval 18"/>
           <p:cNvSpPr/>
           <p:nvPr/>
         </p:nvSpPr>
@@ -14134,7 +14264,7 @@
       </p:sp>
       <p:sp>
         <p:nvSpPr>
-          <p:cNvPr id="19" name="Oval 18"/>
+          <p:cNvPr id="20" name="Oval 19"/>
           <p:cNvSpPr/>
           <p:nvPr/>
         </p:nvSpPr>
@@ -14179,7 +14309,7 @@
       </p:sp>
       <p:sp>
         <p:nvSpPr>
-          <p:cNvPr id="20" name="Oval 19"/>
+          <p:cNvPr id="21" name="Oval 20"/>
           <p:cNvSpPr/>
           <p:nvPr/>
         </p:nvSpPr>
@@ -14224,7 +14354,7 @@
       </p:sp>
       <p:sp>
         <p:nvSpPr>
-          <p:cNvPr id="21" name="Oval 20"/>
+          <p:cNvPr id="22" name="Oval 21"/>
           <p:cNvSpPr/>
           <p:nvPr/>
         </p:nvSpPr>
@@ -14269,7 +14399,7 @@
       </p:sp>
       <p:sp>
         <p:nvSpPr>
-          <p:cNvPr id="22" name="Oval 21"/>
+          <p:cNvPr id="23" name="Oval 22"/>
           <p:cNvSpPr/>
           <p:nvPr/>
         </p:nvSpPr>
@@ -14314,7 +14444,7 @@
       </p:sp>
       <p:sp>
         <p:nvSpPr>
-          <p:cNvPr id="23" name="Oval 22"/>
+          <p:cNvPr id="24" name="Oval 23"/>
           <p:cNvSpPr/>
           <p:nvPr/>
         </p:nvSpPr>
@@ -14359,7 +14489,7 @@
       </p:sp>
       <p:sp>
         <p:nvSpPr>
-          <p:cNvPr id="24" name="Oval 23"/>
+          <p:cNvPr id="25" name="Oval 24"/>
           <p:cNvSpPr/>
           <p:nvPr/>
         </p:nvSpPr>
@@ -14404,7 +14534,7 @@
       </p:sp>
       <p:sp>
         <p:nvSpPr>
-          <p:cNvPr id="25" name="Oval 24"/>
+          <p:cNvPr id="26" name="Oval 25"/>
           <p:cNvSpPr/>
           <p:nvPr/>
         </p:nvSpPr>
@@ -14449,7 +14579,7 @@
       </p:sp>
       <p:sp>
         <p:nvSpPr>
-          <p:cNvPr id="26" name="Oval 25"/>
+          <p:cNvPr id="27" name="Oval 26"/>
           <p:cNvSpPr/>
           <p:nvPr/>
         </p:nvSpPr>
@@ -14494,7 +14624,7 @@
       </p:sp>
       <p:sp>
         <p:nvSpPr>
-          <p:cNvPr id="27" name="Oval 26"/>
+          <p:cNvPr id="28" name="Oval 27"/>
           <p:cNvSpPr/>
           <p:nvPr/>
         </p:nvSpPr>
@@ -14539,7 +14669,7 @@
       </p:sp>
       <p:sp>
         <p:nvSpPr>
-          <p:cNvPr id="28" name="Oval 27"/>
+          <p:cNvPr id="29" name="Oval 28"/>
           <p:cNvSpPr/>
           <p:nvPr/>
         </p:nvSpPr>
@@ -14584,7 +14714,7 @@
       </p:sp>
       <p:sp>
         <p:nvSpPr>
-          <p:cNvPr id="29" name="Oval 28"/>
+          <p:cNvPr id="30" name="Oval 29"/>
           <p:cNvSpPr/>
           <p:nvPr/>
         </p:nvSpPr>
@@ -14629,7 +14759,7 @@
       </p:sp>
       <p:sp>
         <p:nvSpPr>
-          <p:cNvPr id="30" name="Oval 29"/>
+          <p:cNvPr id="31" name="Oval 30"/>
           <p:cNvSpPr/>
           <p:nvPr/>
         </p:nvSpPr>
@@ -14674,7 +14804,7 @@
       </p:sp>
       <p:sp>
         <p:nvSpPr>
-          <p:cNvPr id="31" name="Oval 30"/>
+          <p:cNvPr id="32" name="Oval 31"/>
           <p:cNvSpPr/>
           <p:nvPr/>
         </p:nvSpPr>
@@ -14719,7 +14849,7 @@
       </p:sp>
       <p:sp>
         <p:nvSpPr>
-          <p:cNvPr id="32" name="Oval 31"/>
+          <p:cNvPr id="33" name="Oval 32"/>
           <p:cNvSpPr/>
           <p:nvPr/>
         </p:nvSpPr>
@@ -14764,7 +14894,7 @@
       </p:sp>
       <p:sp>
         <p:nvSpPr>
-          <p:cNvPr id="33" name="Oval 32"/>
+          <p:cNvPr id="34" name="Oval 33"/>
           <p:cNvSpPr/>
           <p:nvPr/>
         </p:nvSpPr>
@@ -14809,7 +14939,7 @@
       </p:sp>
       <p:sp>
         <p:nvSpPr>
-          <p:cNvPr id="34" name="Oval 33"/>
+          <p:cNvPr id="35" name="Oval 34"/>
           <p:cNvSpPr/>
           <p:nvPr/>
         </p:nvSpPr>
@@ -14854,7 +14984,7 @@
       </p:sp>
       <p:sp>
         <p:nvSpPr>
-          <p:cNvPr id="35" name="Oval 34"/>
+          <p:cNvPr id="36" name="Oval 35"/>
           <p:cNvSpPr/>
           <p:nvPr/>
         </p:nvSpPr>
@@ -14899,7 +15029,7 @@
       </p:sp>
       <p:sp>
         <p:nvSpPr>
-          <p:cNvPr id="36" name="Oval 35"/>
+          <p:cNvPr id="37" name="Oval 36"/>
           <p:cNvSpPr/>
           <p:nvPr/>
         </p:nvSpPr>
@@ -14944,7 +15074,7 @@
       </p:sp>
       <p:sp>
         <p:nvSpPr>
-          <p:cNvPr id="37" name="Rounded Rectangle 36"/>
+          <p:cNvPr id="38" name="Rounded Rectangle 37"/>
           <p:cNvSpPr/>
           <p:nvPr/>
         </p:nvSpPr>
@@ -14989,7 +15119,7 @@
       </p:sp>
       <p:sp>
         <p:nvSpPr>
-          <p:cNvPr id="38" name="Rectangle 37"/>
+          <p:cNvPr id="39" name="Rectangle 38"/>
           <p:cNvSpPr/>
           <p:nvPr/>
         </p:nvSpPr>
@@ -15032,7 +15162,7 @@
       </p:sp>
       <p:sp>
         <p:nvSpPr>
-          <p:cNvPr id="39" name="Oval 38"/>
+          <p:cNvPr id="40" name="Oval 39"/>
           <p:cNvSpPr/>
           <p:nvPr/>
         </p:nvSpPr>
@@ -15077,7 +15207,7 @@
       </p:sp>
       <p:sp>
         <p:nvSpPr>
-          <p:cNvPr id="40" name="TextBox 39"/>
+          <p:cNvPr id="41" name="TextBox 40"/>
           <p:cNvSpPr txBox="1"/>
           <p:nvPr/>
         </p:nvSpPr>
@@ -15113,7 +15243,7 @@
       </p:sp>
       <p:sp>
         <p:nvSpPr>
-          <p:cNvPr id="41" name="Rectangle 40"/>
+          <p:cNvPr id="42" name="Rectangle 41"/>
           <p:cNvSpPr/>
           <p:nvPr/>
         </p:nvSpPr>
@@ -15156,7 +15286,7 @@
       </p:sp>
       <p:sp>
         <p:nvSpPr>
-          <p:cNvPr id="42" name="TextBox 41"/>
+          <p:cNvPr id="43" name="TextBox 42"/>
           <p:cNvSpPr txBox="1"/>
           <p:nvPr/>
         </p:nvSpPr>
@@ -15177,7 +15307,7 @@
           <a:lstStyle/>
           <a:p>
             <a:pPr algn="ctr">
-              <a:defRPr sz="1800" b="1" i="0">
+              <a:defRPr sz="2200" b="1" i="0">
                 <a:solidFill>
                   <a:srgbClr val="FFFFFF"/>
                 </a:solidFill>
@@ -15196,7 +15326,7 @@
       </p:sp>
       <p:sp>
         <p:nvSpPr>
-          <p:cNvPr id="43" name="Oval 42"/>
+          <p:cNvPr id="44" name="Oval 43"/>
           <p:cNvSpPr/>
           <p:nvPr/>
         </p:nvSpPr>
@@ -15241,7 +15371,7 @@
       </p:sp>
       <p:sp>
         <p:nvSpPr>
-          <p:cNvPr id="44" name="Oval 43"/>
+          <p:cNvPr id="45" name="Oval 44"/>
           <p:cNvSpPr/>
           <p:nvPr/>
         </p:nvSpPr>
@@ -15286,7 +15416,7 @@
       </p:sp>
       <p:sp>
         <p:nvSpPr>
-          <p:cNvPr id="45" name="Oval 44"/>
+          <p:cNvPr id="46" name="Oval 45"/>
           <p:cNvSpPr/>
           <p:nvPr/>
         </p:nvSpPr>
@@ -15331,7 +15461,7 @@
       </p:sp>
       <p:sp>
         <p:nvSpPr>
-          <p:cNvPr id="46" name="Oval 45"/>
+          <p:cNvPr id="47" name="Oval 46"/>
           <p:cNvSpPr/>
           <p:nvPr/>
         </p:nvSpPr>
@@ -15376,7 +15506,7 @@
       </p:sp>
       <p:sp>
         <p:nvSpPr>
-          <p:cNvPr id="47" name="Oval 46"/>
+          <p:cNvPr id="48" name="Oval 47"/>
           <p:cNvSpPr/>
           <p:nvPr/>
         </p:nvSpPr>
@@ -15421,7 +15551,7 @@
       </p:sp>
       <p:sp>
         <p:nvSpPr>
-          <p:cNvPr id="48" name="Oval 47"/>
+          <p:cNvPr id="49" name="Oval 48"/>
           <p:cNvSpPr/>
           <p:nvPr/>
         </p:nvSpPr>
@@ -15466,7 +15596,7 @@
       </p:sp>
       <p:sp>
         <p:nvSpPr>
-          <p:cNvPr id="49" name="Rounded Rectangle 48"/>
+          <p:cNvPr id="50" name="Rounded Rectangle 49"/>
           <p:cNvSpPr/>
           <p:nvPr/>
         </p:nvSpPr>
@@ -15511,7 +15641,7 @@
       </p:sp>
       <p:sp>
         <p:nvSpPr>
-          <p:cNvPr id="50" name="Rectangle 49"/>
+          <p:cNvPr id="51" name="Rectangle 50"/>
           <p:cNvSpPr/>
           <p:nvPr/>
         </p:nvSpPr>
@@ -15554,7 +15684,7 @@
       </p:sp>
       <p:sp>
         <p:nvSpPr>
-          <p:cNvPr id="51" name="Oval 50"/>
+          <p:cNvPr id="52" name="Oval 51"/>
           <p:cNvSpPr/>
           <p:nvPr/>
         </p:nvSpPr>
@@ -15599,7 +15729,7 @@
       </p:sp>
       <p:sp>
         <p:nvSpPr>
-          <p:cNvPr id="52" name="TextBox 51"/>
+          <p:cNvPr id="53" name="TextBox 52"/>
           <p:cNvSpPr txBox="1"/>
           <p:nvPr/>
         </p:nvSpPr>
@@ -15635,7 +15765,7 @@
       </p:sp>
       <p:sp>
         <p:nvSpPr>
-          <p:cNvPr id="53" name="Rectangle 52"/>
+          <p:cNvPr id="54" name="Rectangle 53"/>
           <p:cNvSpPr/>
           <p:nvPr/>
         </p:nvSpPr>
@@ -15678,7 +15808,7 @@
       </p:sp>
       <p:sp>
         <p:nvSpPr>
-          <p:cNvPr id="54" name="TextBox 53"/>
+          <p:cNvPr id="55" name="TextBox 54"/>
           <p:cNvSpPr txBox="1"/>
           <p:nvPr/>
         </p:nvSpPr>
@@ -15699,7 +15829,7 @@
           <a:lstStyle/>
           <a:p>
             <a:pPr algn="ctr">
-              <a:defRPr sz="1800" b="1" i="0">
+              <a:defRPr sz="2200" b="1" i="0">
                 <a:solidFill>
                   <a:srgbClr val="FFFFFF"/>
                 </a:solidFill>
@@ -15718,7 +15848,7 @@
       </p:sp>
       <p:sp>
         <p:nvSpPr>
-          <p:cNvPr id="55" name="Oval 54"/>
+          <p:cNvPr id="56" name="Oval 55"/>
           <p:cNvSpPr/>
           <p:nvPr/>
         </p:nvSpPr>
@@ -15763,7 +15893,7 @@
       </p:sp>
       <p:sp>
         <p:nvSpPr>
-          <p:cNvPr id="56" name="Oval 55"/>
+          <p:cNvPr id="57" name="Oval 56"/>
           <p:cNvSpPr/>
           <p:nvPr/>
         </p:nvSpPr>
@@ -15808,7 +15938,7 @@
       </p:sp>
       <p:sp>
         <p:nvSpPr>
-          <p:cNvPr id="57" name="Oval 56"/>
+          <p:cNvPr id="58" name="Oval 57"/>
           <p:cNvSpPr/>
           <p:nvPr/>
         </p:nvSpPr>
@@ -15853,7 +15983,7 @@
       </p:sp>
       <p:sp>
         <p:nvSpPr>
-          <p:cNvPr id="58" name="Oval 57"/>
+          <p:cNvPr id="59" name="Oval 58"/>
           <p:cNvSpPr/>
           <p:nvPr/>
         </p:nvSpPr>
@@ -15898,7 +16028,7 @@
       </p:sp>
       <p:sp>
         <p:nvSpPr>
-          <p:cNvPr id="59" name="Oval 58"/>
+          <p:cNvPr id="60" name="Oval 59"/>
           <p:cNvSpPr/>
           <p:nvPr/>
         </p:nvSpPr>
@@ -15943,7 +16073,7 @@
       </p:sp>
       <p:sp>
         <p:nvSpPr>
-          <p:cNvPr id="60" name="Oval 59"/>
+          <p:cNvPr id="61" name="Oval 60"/>
           <p:cNvSpPr/>
           <p:nvPr/>
         </p:nvSpPr>
@@ -15988,7 +16118,7 @@
       </p:sp>
       <p:sp>
         <p:nvSpPr>
-          <p:cNvPr id="61" name="Rounded Rectangle 60"/>
+          <p:cNvPr id="62" name="Rounded Rectangle 61"/>
           <p:cNvSpPr/>
           <p:nvPr/>
         </p:nvSpPr>
@@ -16033,7 +16163,7 @@
       </p:sp>
       <p:sp>
         <p:nvSpPr>
-          <p:cNvPr id="62" name="Rectangle 61"/>
+          <p:cNvPr id="63" name="Rectangle 62"/>
           <p:cNvSpPr/>
           <p:nvPr/>
         </p:nvSpPr>
@@ -16076,7 +16206,7 @@
       </p:sp>
       <p:sp>
         <p:nvSpPr>
-          <p:cNvPr id="63" name="Oval 62"/>
+          <p:cNvPr id="64" name="Oval 63"/>
           <p:cNvSpPr/>
           <p:nvPr/>
         </p:nvSpPr>
@@ -16121,7 +16251,7 @@
       </p:sp>
       <p:sp>
         <p:nvSpPr>
-          <p:cNvPr id="64" name="TextBox 63"/>
+          <p:cNvPr id="65" name="TextBox 64"/>
           <p:cNvSpPr txBox="1"/>
           <p:nvPr/>
         </p:nvSpPr>
@@ -16157,7 +16287,7 @@
       </p:sp>
       <p:sp>
         <p:nvSpPr>
-          <p:cNvPr id="65" name="Rectangle 64"/>
+          <p:cNvPr id="66" name="Rectangle 65"/>
           <p:cNvSpPr/>
           <p:nvPr/>
         </p:nvSpPr>
@@ -16200,7 +16330,7 @@
       </p:sp>
       <p:sp>
         <p:nvSpPr>
-          <p:cNvPr id="66" name="TextBox 65"/>
+          <p:cNvPr id="67" name="TextBox 66"/>
           <p:cNvSpPr txBox="1"/>
           <p:nvPr/>
         </p:nvSpPr>
@@ -16221,7 +16351,7 @@
           <a:lstStyle/>
           <a:p>
             <a:pPr algn="ctr">
-              <a:defRPr sz="1800" b="1" i="0">
+              <a:defRPr sz="2200" b="1" i="0">
                 <a:solidFill>
                   <a:srgbClr val="FFFFFF"/>
                 </a:solidFill>
@@ -16240,7 +16370,7 @@
       </p:sp>
       <p:sp>
         <p:nvSpPr>
-          <p:cNvPr id="67" name="Oval 66"/>
+          <p:cNvPr id="68" name="Oval 67"/>
           <p:cNvSpPr/>
           <p:nvPr/>
         </p:nvSpPr>
@@ -16285,7 +16415,7 @@
       </p:sp>
       <p:sp>
         <p:nvSpPr>
-          <p:cNvPr id="68" name="Oval 67"/>
+          <p:cNvPr id="69" name="Oval 68"/>
           <p:cNvSpPr/>
           <p:nvPr/>
         </p:nvSpPr>
@@ -16330,7 +16460,7 @@
       </p:sp>
       <p:sp>
         <p:nvSpPr>
-          <p:cNvPr id="69" name="Oval 68"/>
+          <p:cNvPr id="70" name="Oval 69"/>
           <p:cNvSpPr/>
           <p:nvPr/>
         </p:nvSpPr>
@@ -16375,7 +16505,7 @@
       </p:sp>
       <p:sp>
         <p:nvSpPr>
-          <p:cNvPr id="70" name="Oval 69"/>
+          <p:cNvPr id="71" name="Oval 70"/>
           <p:cNvSpPr/>
           <p:nvPr/>
         </p:nvSpPr>
@@ -16420,7 +16550,7 @@
       </p:sp>
       <p:sp>
         <p:nvSpPr>
-          <p:cNvPr id="71" name="Oval 70"/>
+          <p:cNvPr id="72" name="Oval 71"/>
           <p:cNvSpPr/>
           <p:nvPr/>
         </p:nvSpPr>
@@ -16465,7 +16595,7 @@
       </p:sp>
       <p:sp>
         <p:nvSpPr>
-          <p:cNvPr id="72" name="Oval 71"/>
+          <p:cNvPr id="73" name="Oval 72"/>
           <p:cNvSpPr/>
           <p:nvPr/>
         </p:nvSpPr>
@@ -16510,7 +16640,7 @@
       </p:sp>
       <p:sp>
         <p:nvSpPr>
-          <p:cNvPr id="73" name="Rounded Rectangle 72"/>
+          <p:cNvPr id="74" name="Rounded Rectangle 73"/>
           <p:cNvSpPr/>
           <p:nvPr/>
         </p:nvSpPr>
@@ -16555,7 +16685,7 @@
       </p:sp>
       <p:sp>
         <p:nvSpPr>
-          <p:cNvPr id="74" name="TextBox 73"/>
+          <p:cNvPr id="75" name="TextBox 74"/>
           <p:cNvSpPr txBox="1"/>
           <p:nvPr/>
         </p:nvSpPr>
@@ -16591,7 +16721,7 @@
       </p:sp>
       <p:sp>
         <p:nvSpPr>
-          <p:cNvPr id="75" name="Rectangle 74"/>
+          <p:cNvPr id="76" name="Rectangle 75"/>
           <p:cNvSpPr/>
           <p:nvPr/>
         </p:nvSpPr>
@@ -16634,7 +16764,7 @@
       </p:sp>
       <p:sp>
         <p:nvSpPr>
-          <p:cNvPr id="76" name="TextBox 75"/>
+          <p:cNvPr id="77" name="TextBox 76"/>
           <p:cNvSpPr txBox="1"/>
           <p:nvPr/>
         </p:nvSpPr>
@@ -16670,7 +16800,7 @@
       </p:sp>
       <p:pic>
         <p:nvPicPr>
-          <p:cNvPr id="77" name="Picture 76" descr="logo-wolf.png"/>
+          <p:cNvPr id="78" name="Picture 77" descr="logo-wolf.png"/>
           <p:cNvPicPr>
             <a:picLocks noChangeAspect="1"/>
           </p:cNvPicPr>
@@ -16718,9 +16848,35 @@
         <p:nvPr/>
       </p:nvGrpSpPr>
       <p:grpSpPr/>
-      <p:sp>
-        <p:nvSpPr>
-          <p:cNvPr id="2" name="Rectangle 1"/>
+      <p:pic>
+        <p:nvPicPr>
+          <p:cNvPr id="2" name="Picture 1" descr="logo-wolf.png"/>
+          <p:cNvPicPr>
+            <a:picLocks noChangeAspect="1"/>
+          </p:cNvPicPr>
+          <p:nvPr/>
+        </p:nvPicPr>
+        <p:blipFill>
+          <a:blip r:embed="rId2">
+            <a:alphaModFix amt="8000"/>
+          </a:blip>
+          <a:stretch>
+            <a:fillRect/>
+          </a:stretch>
+        </p:blipFill>
+        <p:spPr>
+          <a:xfrm>
+            <a:off x="3840480" y="1371600"/>
+            <a:ext cx="4572000" cy="4572000"/>
+          </a:xfrm>
+          <a:prstGeom prst="rect">
+            <a:avLst/>
+          </a:prstGeom>
+        </p:spPr>
+      </p:pic>
+      <p:sp>
+        <p:nvSpPr>
+          <p:cNvPr id="3" name="Rectangle 2"/>
           <p:cNvSpPr/>
           <p:nvPr/>
         </p:nvSpPr>
@@ -16765,7 +16921,7 @@
       </p:sp>
       <p:sp>
         <p:nvSpPr>
-          <p:cNvPr id="3" name="Rectangle 2"/>
+          <p:cNvPr id="4" name="Rectangle 3"/>
           <p:cNvSpPr/>
           <p:nvPr/>
         </p:nvSpPr>
@@ -16810,7 +16966,7 @@
       </p:sp>
       <p:sp>
         <p:nvSpPr>
-          <p:cNvPr id="4" name="Oval 3"/>
+          <p:cNvPr id="5" name="Oval 4"/>
           <p:cNvSpPr/>
           <p:nvPr/>
         </p:nvSpPr>
@@ -16855,7 +17011,7 @@
       </p:sp>
       <p:sp>
         <p:nvSpPr>
-          <p:cNvPr id="5" name="Oval 4"/>
+          <p:cNvPr id="6" name="Oval 5"/>
           <p:cNvSpPr/>
           <p:nvPr/>
         </p:nvSpPr>
@@ -16900,7 +17056,7 @@
       </p:sp>
       <p:sp>
         <p:nvSpPr>
-          <p:cNvPr id="6" name="Oval 5"/>
+          <p:cNvPr id="7" name="Oval 6"/>
           <p:cNvSpPr/>
           <p:nvPr/>
         </p:nvSpPr>
@@ -16945,7 +17101,7 @@
       </p:sp>
       <p:sp>
         <p:nvSpPr>
-          <p:cNvPr id="7" name="Oval 6"/>
+          <p:cNvPr id="8" name="Oval 7"/>
           <p:cNvSpPr/>
           <p:nvPr/>
         </p:nvSpPr>
@@ -16990,7 +17146,7 @@
       </p:sp>
       <p:sp>
         <p:nvSpPr>
-          <p:cNvPr id="8" name="Oval 7"/>
+          <p:cNvPr id="9" name="Oval 8"/>
           <p:cNvSpPr/>
           <p:nvPr/>
         </p:nvSpPr>
@@ -17035,7 +17191,7 @@
       </p:sp>
       <p:sp>
         <p:nvSpPr>
-          <p:cNvPr id="9" name="Oval 8"/>
+          <p:cNvPr id="10" name="Oval 9"/>
           <p:cNvSpPr/>
           <p:nvPr/>
         </p:nvSpPr>
@@ -17080,7 +17236,7 @@
       </p:sp>
       <p:sp>
         <p:nvSpPr>
-          <p:cNvPr id="10" name="Oval 9"/>
+          <p:cNvPr id="11" name="Oval 10"/>
           <p:cNvSpPr/>
           <p:nvPr/>
         </p:nvSpPr>
@@ -17125,7 +17281,7 @@
       </p:sp>
       <p:sp>
         <p:nvSpPr>
-          <p:cNvPr id="11" name="Oval 10"/>
+          <p:cNvPr id="12" name="Oval 11"/>
           <p:cNvSpPr/>
           <p:nvPr/>
         </p:nvSpPr>
@@ -17170,7 +17326,7 @@
       </p:sp>
       <p:sp>
         <p:nvSpPr>
-          <p:cNvPr id="12" name="Oval 11"/>
+          <p:cNvPr id="13" name="Oval 12"/>
           <p:cNvSpPr/>
           <p:nvPr/>
         </p:nvSpPr>
@@ -17215,7 +17371,7 @@
       </p:sp>
       <p:sp>
         <p:nvSpPr>
-          <p:cNvPr id="13" name="Oval 12"/>
+          <p:cNvPr id="14" name="Oval 13"/>
           <p:cNvSpPr/>
           <p:nvPr/>
         </p:nvSpPr>
@@ -17260,7 +17416,7 @@
       </p:sp>
       <p:sp>
         <p:nvSpPr>
-          <p:cNvPr id="14" name="Oval 13"/>
+          <p:cNvPr id="15" name="Oval 14"/>
           <p:cNvSpPr/>
           <p:nvPr/>
         </p:nvSpPr>
@@ -17305,7 +17461,7 @@
       </p:sp>
       <p:sp>
         <p:nvSpPr>
-          <p:cNvPr id="15" name="Oval 14"/>
+          <p:cNvPr id="16" name="Oval 15"/>
           <p:cNvSpPr/>
           <p:nvPr/>
         </p:nvSpPr>
@@ -17350,7 +17506,7 @@
       </p:sp>
       <p:sp>
         <p:nvSpPr>
-          <p:cNvPr id="16" name="Oval 15"/>
+          <p:cNvPr id="17" name="Oval 16"/>
           <p:cNvSpPr/>
           <p:nvPr/>
         </p:nvSpPr>
@@ -17395,7 +17551,7 @@
       </p:sp>
       <p:sp>
         <p:nvSpPr>
-          <p:cNvPr id="17" name="Oval 16"/>
+          <p:cNvPr id="18" name="Oval 17"/>
           <p:cNvSpPr/>
           <p:nvPr/>
         </p:nvSpPr>
@@ -17440,7 +17596,7 @@
       </p:sp>
       <p:sp>
         <p:nvSpPr>
-          <p:cNvPr id="18" name="Oval 17"/>
+          <p:cNvPr id="19" name="Oval 18"/>
           <p:cNvSpPr/>
           <p:nvPr/>
         </p:nvSpPr>
@@ -17485,7 +17641,7 @@
       </p:sp>
       <p:sp>
         <p:nvSpPr>
-          <p:cNvPr id="19" name="Oval 18"/>
+          <p:cNvPr id="20" name="Oval 19"/>
           <p:cNvSpPr/>
           <p:nvPr/>
         </p:nvSpPr>
@@ -17530,7 +17686,7 @@
       </p:sp>
       <p:sp>
         <p:nvSpPr>
-          <p:cNvPr id="20" name="Oval 19"/>
+          <p:cNvPr id="21" name="Oval 20"/>
           <p:cNvSpPr/>
           <p:nvPr/>
         </p:nvSpPr>
@@ -17575,7 +17731,7 @@
       </p:sp>
       <p:sp>
         <p:nvSpPr>
-          <p:cNvPr id="21" name="Oval 20"/>
+          <p:cNvPr id="22" name="Oval 21"/>
           <p:cNvSpPr/>
           <p:nvPr/>
         </p:nvSpPr>
@@ -17620,7 +17776,7 @@
       </p:sp>
       <p:sp>
         <p:nvSpPr>
-          <p:cNvPr id="22" name="Oval 21"/>
+          <p:cNvPr id="23" name="Oval 22"/>
           <p:cNvSpPr/>
           <p:nvPr/>
         </p:nvSpPr>
@@ -17665,7 +17821,7 @@
       </p:sp>
       <p:sp>
         <p:nvSpPr>
-          <p:cNvPr id="23" name="Oval 22"/>
+          <p:cNvPr id="24" name="Oval 23"/>
           <p:cNvSpPr/>
           <p:nvPr/>
         </p:nvSpPr>
@@ -17710,7 +17866,7 @@
       </p:sp>
       <p:sp>
         <p:nvSpPr>
-          <p:cNvPr id="24" name="Oval 23"/>
+          <p:cNvPr id="25" name="Oval 24"/>
           <p:cNvSpPr/>
           <p:nvPr/>
         </p:nvSpPr>
@@ -17755,7 +17911,7 @@
       </p:sp>
       <p:sp>
         <p:nvSpPr>
-          <p:cNvPr id="25" name="Oval 24"/>
+          <p:cNvPr id="26" name="Oval 25"/>
           <p:cNvSpPr/>
           <p:nvPr/>
         </p:nvSpPr>
@@ -17800,7 +17956,7 @@
       </p:sp>
       <p:sp>
         <p:nvSpPr>
-          <p:cNvPr id="26" name="Oval 25"/>
+          <p:cNvPr id="27" name="Oval 26"/>
           <p:cNvSpPr/>
           <p:nvPr/>
         </p:nvSpPr>
@@ -17845,7 +18001,7 @@
       </p:sp>
       <p:sp>
         <p:nvSpPr>
-          <p:cNvPr id="27" name="Oval 26"/>
+          <p:cNvPr id="28" name="Oval 27"/>
           <p:cNvSpPr/>
           <p:nvPr/>
         </p:nvSpPr>
@@ -17890,7 +18046,7 @@
       </p:sp>
       <p:sp>
         <p:nvSpPr>
-          <p:cNvPr id="28" name="Oval 27"/>
+          <p:cNvPr id="29" name="Oval 28"/>
           <p:cNvSpPr/>
           <p:nvPr/>
         </p:nvSpPr>
@@ -17935,7 +18091,7 @@
       </p:sp>
       <p:sp>
         <p:nvSpPr>
-          <p:cNvPr id="29" name="Oval 28"/>
+          <p:cNvPr id="30" name="Oval 29"/>
           <p:cNvSpPr/>
           <p:nvPr/>
         </p:nvSpPr>
@@ -17980,7 +18136,7 @@
       </p:sp>
       <p:sp>
         <p:nvSpPr>
-          <p:cNvPr id="30" name="Oval 29"/>
+          <p:cNvPr id="31" name="Oval 30"/>
           <p:cNvSpPr/>
           <p:nvPr/>
         </p:nvSpPr>
@@ -18025,7 +18181,7 @@
       </p:sp>
       <p:sp>
         <p:nvSpPr>
-          <p:cNvPr id="31" name="Oval 30"/>
+          <p:cNvPr id="32" name="Oval 31"/>
           <p:cNvSpPr/>
           <p:nvPr/>
         </p:nvSpPr>
@@ -18070,7 +18226,7 @@
       </p:sp>
       <p:sp>
         <p:nvSpPr>
-          <p:cNvPr id="32" name="Oval 31"/>
+          <p:cNvPr id="33" name="Oval 32"/>
           <p:cNvSpPr/>
           <p:nvPr/>
         </p:nvSpPr>
@@ -18115,7 +18271,7 @@
       </p:sp>
       <p:sp>
         <p:nvSpPr>
-          <p:cNvPr id="33" name="Oval 32"/>
+          <p:cNvPr id="34" name="Oval 33"/>
           <p:cNvSpPr/>
           <p:nvPr/>
         </p:nvSpPr>
@@ -18160,7 +18316,7 @@
       </p:sp>
       <p:sp>
         <p:nvSpPr>
-          <p:cNvPr id="34" name="Oval 33"/>
+          <p:cNvPr id="35" name="Oval 34"/>
           <p:cNvSpPr/>
           <p:nvPr/>
         </p:nvSpPr>
@@ -18205,7 +18361,7 @@
       </p:sp>
       <p:sp>
         <p:nvSpPr>
-          <p:cNvPr id="35" name="Oval 34"/>
+          <p:cNvPr id="36" name="Oval 35"/>
           <p:cNvSpPr/>
           <p:nvPr/>
         </p:nvSpPr>
@@ -18250,7 +18406,7 @@
       </p:sp>
       <p:pic>
         <p:nvPicPr>
-          <p:cNvPr id="36" name="Picture 35" descr="logo-wolf.png"/>
+          <p:cNvPr id="37" name="Picture 36" descr="logo-wolf.png"/>
           <p:cNvPicPr>
             <a:picLocks noChangeAspect="1"/>
           </p:cNvPicPr>
@@ -18274,7 +18430,7 @@
       </p:pic>
       <p:sp>
         <p:nvSpPr>
-          <p:cNvPr id="37" name="Rectangle 36"/>
+          <p:cNvPr id="38" name="Rectangle 37"/>
           <p:cNvSpPr/>
           <p:nvPr/>
         </p:nvSpPr>
@@ -18317,7 +18473,7 @@
       </p:sp>
       <p:sp>
         <p:nvSpPr>
-          <p:cNvPr id="38" name="Rectangle 37"/>
+          <p:cNvPr id="39" name="Rectangle 38"/>
           <p:cNvSpPr/>
           <p:nvPr/>
         </p:nvSpPr>
@@ -18360,7 +18516,7 @@
       </p:sp>
       <p:sp>
         <p:nvSpPr>
-          <p:cNvPr id="39" name="TextBox 38"/>
+          <p:cNvPr id="40" name="TextBox 39"/>
           <p:cNvSpPr txBox="1"/>
           <p:nvPr/>
         </p:nvSpPr>
@@ -18381,7 +18537,7 @@
           <a:lstStyle/>
           <a:p>
             <a:pPr algn="ctr">
-              <a:defRPr sz="5600" b="1" i="0">
+              <a:defRPr sz="6800" b="1" i="0">
                 <a:solidFill>
                   <a:srgbClr val="FFFFFF"/>
                 </a:solidFill>
@@ -18396,7 +18552,7 @@
       </p:sp>
       <p:sp>
         <p:nvSpPr>
-          <p:cNvPr id="40" name="Rectangle 39"/>
+          <p:cNvPr id="41" name="Rectangle 40"/>
           <p:cNvSpPr/>
           <p:nvPr/>
         </p:nvSpPr>
@@ -18439,7 +18595,7 @@
       </p:sp>
       <p:sp>
         <p:nvSpPr>
-          <p:cNvPr id="41" name="Rectangle 40"/>
+          <p:cNvPr id="42" name="Rectangle 41"/>
           <p:cNvSpPr/>
           <p:nvPr/>
         </p:nvSpPr>
@@ -18482,7 +18638,7 @@
       </p:sp>
       <p:sp>
         <p:nvSpPr>
-          <p:cNvPr id="42" name="TextBox 41"/>
+          <p:cNvPr id="43" name="TextBox 42"/>
           <p:cNvSpPr txBox="1"/>
           <p:nvPr/>
         </p:nvSpPr>
@@ -18518,7 +18674,7 @@
       </p:sp>
       <p:sp>
         <p:nvSpPr>
-          <p:cNvPr id="43" name="Rounded Rectangle 42"/>
+          <p:cNvPr id="44" name="Rounded Rectangle 43"/>
           <p:cNvSpPr/>
           <p:nvPr/>
         </p:nvSpPr>
@@ -18563,7 +18719,7 @@
       </p:sp>
       <p:sp>
         <p:nvSpPr>
-          <p:cNvPr id="44" name="Rectangle 43"/>
+          <p:cNvPr id="45" name="Rectangle 44"/>
           <p:cNvSpPr/>
           <p:nvPr/>
         </p:nvSpPr>
@@ -18606,7 +18762,7 @@
       </p:sp>
       <p:sp>
         <p:nvSpPr>
-          <p:cNvPr id="45" name="TextBox 44"/>
+          <p:cNvPr id="46" name="TextBox 45"/>
           <p:cNvSpPr txBox="1"/>
           <p:nvPr/>
         </p:nvSpPr>
@@ -18642,7 +18798,7 @@
       </p:sp>
       <p:sp>
         <p:nvSpPr>
-          <p:cNvPr id="46" name="TextBox 45"/>
+          <p:cNvPr id="47" name="TextBox 46"/>
           <p:cNvSpPr txBox="1"/>
           <p:nvPr/>
         </p:nvSpPr>
@@ -18678,7 +18834,7 @@
       </p:sp>
       <p:sp>
         <p:nvSpPr>
-          <p:cNvPr id="47" name="TextBox 46"/>
+          <p:cNvPr id="48" name="TextBox 47"/>
           <p:cNvSpPr txBox="1"/>
           <p:nvPr/>
         </p:nvSpPr>
@@ -18714,7 +18870,7 @@
       </p:sp>
       <p:sp>
         <p:nvSpPr>
-          <p:cNvPr id="48" name="TextBox 47"/>
+          <p:cNvPr id="49" name="TextBox 48"/>
           <p:cNvSpPr txBox="1"/>
           <p:nvPr/>
         </p:nvSpPr>
@@ -18750,7 +18906,7 @@
       </p:sp>
       <p:sp>
         <p:nvSpPr>
-          <p:cNvPr id="49" name="Rectangle 48"/>
+          <p:cNvPr id="50" name="Rectangle 49"/>
           <p:cNvSpPr/>
           <p:nvPr/>
         </p:nvSpPr>
@@ -18793,7 +18949,7 @@
       </p:sp>
       <p:sp>
         <p:nvSpPr>
-          <p:cNvPr id="50" name="TextBox 49"/>
+          <p:cNvPr id="51" name="TextBox 50"/>
           <p:cNvSpPr txBox="1"/>
           <p:nvPr/>
         </p:nvSpPr>
@@ -18853,9 +19009,35 @@
         <p:nvPr/>
       </p:nvGrpSpPr>
       <p:grpSpPr/>
-      <p:sp>
-        <p:nvSpPr>
-          <p:cNvPr id="2" name="Rectangle 1"/>
+      <p:pic>
+        <p:nvPicPr>
+          <p:cNvPr id="2" name="Picture 1" descr="logo-wolf.png"/>
+          <p:cNvPicPr>
+            <a:picLocks noChangeAspect="1"/>
+          </p:cNvPicPr>
+          <p:nvPr/>
+        </p:nvPicPr>
+        <p:blipFill>
+          <a:blip r:embed="rId2">
+            <a:alphaModFix amt="8000"/>
+          </a:blip>
+          <a:stretch>
+            <a:fillRect/>
+          </a:stretch>
+        </p:blipFill>
+        <p:spPr>
+          <a:xfrm>
+            <a:off x="3840480" y="1371600"/>
+            <a:ext cx="4572000" cy="4572000"/>
+          </a:xfrm>
+          <a:prstGeom prst="rect">
+            <a:avLst/>
+          </a:prstGeom>
+        </p:spPr>
+      </p:pic>
+      <p:sp>
+        <p:nvSpPr>
+          <p:cNvPr id="3" name="Rectangle 2"/>
           <p:cNvSpPr/>
           <p:nvPr/>
         </p:nvSpPr>
@@ -18900,7 +19082,7 @@
       </p:sp>
       <p:sp>
         <p:nvSpPr>
-          <p:cNvPr id="3" name="Rectangle 2"/>
+          <p:cNvPr id="4" name="Rectangle 3"/>
           <p:cNvSpPr/>
           <p:nvPr/>
         </p:nvSpPr>
@@ -18945,7 +19127,7 @@
       </p:sp>
       <p:sp>
         <p:nvSpPr>
-          <p:cNvPr id="4" name="Rectangle 3"/>
+          <p:cNvPr id="5" name="Rectangle 4"/>
           <p:cNvSpPr/>
           <p:nvPr/>
         </p:nvSpPr>
@@ -18990,7 +19172,7 @@
       </p:sp>
       <p:sp>
         <p:nvSpPr>
-          <p:cNvPr id="5" name="Rectangle 4"/>
+          <p:cNvPr id="6" name="Rectangle 5"/>
           <p:cNvSpPr/>
           <p:nvPr/>
         </p:nvSpPr>
@@ -19033,7 +19215,7 @@
       </p:sp>
       <p:sp>
         <p:nvSpPr>
-          <p:cNvPr id="6" name="Oval 5"/>
+          <p:cNvPr id="7" name="Oval 6"/>
           <p:cNvSpPr/>
           <p:nvPr/>
         </p:nvSpPr>
@@ -19078,7 +19260,7 @@
       </p:sp>
       <p:sp>
         <p:nvSpPr>
-          <p:cNvPr id="7" name="Oval 6"/>
+          <p:cNvPr id="8" name="Oval 7"/>
           <p:cNvSpPr/>
           <p:nvPr/>
         </p:nvSpPr>
@@ -19123,7 +19305,7 @@
       </p:sp>
       <p:sp>
         <p:nvSpPr>
-          <p:cNvPr id="8" name="Oval 7"/>
+          <p:cNvPr id="9" name="Oval 8"/>
           <p:cNvSpPr/>
           <p:nvPr/>
         </p:nvSpPr>
@@ -19168,7 +19350,7 @@
       </p:sp>
       <p:sp>
         <p:nvSpPr>
-          <p:cNvPr id="9" name="Oval 8"/>
+          <p:cNvPr id="10" name="Oval 9"/>
           <p:cNvSpPr/>
           <p:nvPr/>
         </p:nvSpPr>
@@ -19213,7 +19395,7 @@
       </p:sp>
       <p:sp>
         <p:nvSpPr>
-          <p:cNvPr id="10" name="Rectangle 9"/>
+          <p:cNvPr id="11" name="Rectangle 10"/>
           <p:cNvSpPr/>
           <p:nvPr/>
         </p:nvSpPr>
@@ -19256,7 +19438,7 @@
       </p:sp>
       <p:sp>
         <p:nvSpPr>
-          <p:cNvPr id="11" name="TextBox 10"/>
+          <p:cNvPr id="12" name="TextBox 11"/>
           <p:cNvSpPr txBox="1"/>
           <p:nvPr/>
         </p:nvSpPr>
@@ -19292,7 +19474,7 @@
       </p:sp>
       <p:sp>
         <p:nvSpPr>
-          <p:cNvPr id="12" name="TextBox 11"/>
+          <p:cNvPr id="13" name="TextBox 12"/>
           <p:cNvSpPr txBox="1"/>
           <p:nvPr/>
         </p:nvSpPr>
@@ -19328,7 +19510,7 @@
       </p:sp>
       <p:sp>
         <p:nvSpPr>
-          <p:cNvPr id="13" name="Rectangle 12"/>
+          <p:cNvPr id="14" name="Rectangle 13"/>
           <p:cNvSpPr/>
           <p:nvPr/>
         </p:nvSpPr>
@@ -19371,7 +19553,7 @@
       </p:sp>
       <p:sp>
         <p:nvSpPr>
-          <p:cNvPr id="14" name="Rounded Rectangle 13"/>
+          <p:cNvPr id="15" name="Rounded Rectangle 14"/>
           <p:cNvSpPr/>
           <p:nvPr/>
         </p:nvSpPr>
@@ -19416,7 +19598,7 @@
       </p:sp>
       <p:sp>
         <p:nvSpPr>
-          <p:cNvPr id="15" name="Rectangle 14"/>
+          <p:cNvPr id="16" name="Rectangle 15"/>
           <p:cNvSpPr/>
           <p:nvPr/>
         </p:nvSpPr>
@@ -19459,7 +19641,7 @@
       </p:sp>
       <p:sp>
         <p:nvSpPr>
-          <p:cNvPr id="16" name="Oval 15"/>
+          <p:cNvPr id="17" name="Oval 16"/>
           <p:cNvSpPr/>
           <p:nvPr/>
         </p:nvSpPr>
@@ -19504,7 +19686,7 @@
       </p:sp>
       <p:sp>
         <p:nvSpPr>
-          <p:cNvPr id="17" name="Oval 16"/>
+          <p:cNvPr id="18" name="Oval 17"/>
           <p:cNvSpPr/>
           <p:nvPr/>
         </p:nvSpPr>
@@ -19547,7 +19729,7 @@
       </p:sp>
       <p:sp>
         <p:nvSpPr>
-          <p:cNvPr id="18" name="TextBox 17"/>
+          <p:cNvPr id="19" name="TextBox 18"/>
           <p:cNvSpPr txBox="1"/>
           <p:nvPr/>
         </p:nvSpPr>
@@ -19583,7 +19765,7 @@
       </p:sp>
       <p:sp>
         <p:nvSpPr>
-          <p:cNvPr id="19" name="TextBox 18"/>
+          <p:cNvPr id="20" name="TextBox 19"/>
           <p:cNvSpPr txBox="1"/>
           <p:nvPr/>
         </p:nvSpPr>
@@ -19604,7 +19786,7 @@
           <a:lstStyle/>
           <a:p>
             <a:pPr algn="l">
-              <a:defRPr sz="1600" b="1" i="0">
+              <a:defRPr sz="1800" b="1" i="0">
                 <a:solidFill>
                   <a:srgbClr val="FFFFFF"/>
                 </a:solidFill>
@@ -19619,7 +19801,7 @@
       </p:sp>
       <p:sp>
         <p:nvSpPr>
-          <p:cNvPr id="20" name="Rectangle 19"/>
+          <p:cNvPr id="21" name="Rectangle 20"/>
           <p:cNvSpPr/>
           <p:nvPr/>
         </p:nvSpPr>
@@ -19662,7 +19844,7 @@
       </p:sp>
       <p:sp>
         <p:nvSpPr>
-          <p:cNvPr id="21" name="TextBox 20"/>
+          <p:cNvPr id="22" name="TextBox 21"/>
           <p:cNvSpPr txBox="1"/>
           <p:nvPr/>
         </p:nvSpPr>
@@ -19698,7 +19880,7 @@
       </p:sp>
       <p:sp>
         <p:nvSpPr>
-          <p:cNvPr id="22" name="Rounded Rectangle 21"/>
+          <p:cNvPr id="23" name="Rounded Rectangle 22"/>
           <p:cNvSpPr/>
           <p:nvPr/>
         </p:nvSpPr>
@@ -19743,7 +19925,7 @@
       </p:sp>
       <p:sp>
         <p:nvSpPr>
-          <p:cNvPr id="23" name="Rectangle 22"/>
+          <p:cNvPr id="24" name="Rectangle 23"/>
           <p:cNvSpPr/>
           <p:nvPr/>
         </p:nvSpPr>
@@ -19786,7 +19968,7 @@
       </p:sp>
       <p:sp>
         <p:nvSpPr>
-          <p:cNvPr id="24" name="Oval 23"/>
+          <p:cNvPr id="25" name="Oval 24"/>
           <p:cNvSpPr/>
           <p:nvPr/>
         </p:nvSpPr>
@@ -19831,7 +20013,7 @@
       </p:sp>
       <p:sp>
         <p:nvSpPr>
-          <p:cNvPr id="25" name="Oval 24"/>
+          <p:cNvPr id="26" name="Oval 25"/>
           <p:cNvSpPr/>
           <p:nvPr/>
         </p:nvSpPr>
@@ -19874,7 +20056,7 @@
       </p:sp>
       <p:sp>
         <p:nvSpPr>
-          <p:cNvPr id="26" name="TextBox 25"/>
+          <p:cNvPr id="27" name="TextBox 26"/>
           <p:cNvSpPr txBox="1"/>
           <p:nvPr/>
         </p:nvSpPr>
@@ -19910,7 +20092,7 @@
       </p:sp>
       <p:sp>
         <p:nvSpPr>
-          <p:cNvPr id="27" name="TextBox 26"/>
+          <p:cNvPr id="28" name="TextBox 27"/>
           <p:cNvSpPr txBox="1"/>
           <p:nvPr/>
         </p:nvSpPr>
@@ -19931,7 +20113,7 @@
           <a:lstStyle/>
           <a:p>
             <a:pPr algn="l">
-              <a:defRPr sz="1600" b="1" i="0">
+              <a:defRPr sz="1800" b="1" i="0">
                 <a:solidFill>
                   <a:srgbClr val="FFFFFF"/>
                 </a:solidFill>
@@ -19946,7 +20128,7 @@
       </p:sp>
       <p:sp>
         <p:nvSpPr>
-          <p:cNvPr id="28" name="Rectangle 27"/>
+          <p:cNvPr id="29" name="Rectangle 28"/>
           <p:cNvSpPr/>
           <p:nvPr/>
         </p:nvSpPr>
@@ -19989,7 +20171,7 @@
       </p:sp>
       <p:sp>
         <p:nvSpPr>
-          <p:cNvPr id="29" name="TextBox 28"/>
+          <p:cNvPr id="30" name="TextBox 29"/>
           <p:cNvSpPr txBox="1"/>
           <p:nvPr/>
         </p:nvSpPr>
@@ -20025,7 +20207,7 @@
       </p:sp>
       <p:sp>
         <p:nvSpPr>
-          <p:cNvPr id="30" name="Rounded Rectangle 29"/>
+          <p:cNvPr id="31" name="Rounded Rectangle 30"/>
           <p:cNvSpPr/>
           <p:nvPr/>
         </p:nvSpPr>
@@ -20070,7 +20252,7 @@
       </p:sp>
       <p:sp>
         <p:nvSpPr>
-          <p:cNvPr id="31" name="Rectangle 30"/>
+          <p:cNvPr id="32" name="Rectangle 31"/>
           <p:cNvSpPr/>
           <p:nvPr/>
         </p:nvSpPr>
@@ -20113,7 +20295,7 @@
       </p:sp>
       <p:sp>
         <p:nvSpPr>
-          <p:cNvPr id="32" name="Oval 31"/>
+          <p:cNvPr id="33" name="Oval 32"/>
           <p:cNvSpPr/>
           <p:nvPr/>
         </p:nvSpPr>
@@ -20158,7 +20340,7 @@
       </p:sp>
       <p:sp>
         <p:nvSpPr>
-          <p:cNvPr id="33" name="Oval 32"/>
+          <p:cNvPr id="34" name="Oval 33"/>
           <p:cNvSpPr/>
           <p:nvPr/>
         </p:nvSpPr>
@@ -20201,7 +20383,7 @@
       </p:sp>
       <p:sp>
         <p:nvSpPr>
-          <p:cNvPr id="34" name="TextBox 33"/>
+          <p:cNvPr id="35" name="TextBox 34"/>
           <p:cNvSpPr txBox="1"/>
           <p:nvPr/>
         </p:nvSpPr>
@@ -20237,7 +20419,7 @@
       </p:sp>
       <p:sp>
         <p:nvSpPr>
-          <p:cNvPr id="35" name="TextBox 34"/>
+          <p:cNvPr id="36" name="TextBox 35"/>
           <p:cNvSpPr txBox="1"/>
           <p:nvPr/>
         </p:nvSpPr>
@@ -20258,7 +20440,7 @@
           <a:lstStyle/>
           <a:p>
             <a:pPr algn="l">
-              <a:defRPr sz="1600" b="1" i="0">
+              <a:defRPr sz="1800" b="1" i="0">
                 <a:solidFill>
                   <a:srgbClr val="FFFFFF"/>
                 </a:solidFill>
@@ -20273,7 +20455,7 @@
       </p:sp>
       <p:sp>
         <p:nvSpPr>
-          <p:cNvPr id="36" name="Rectangle 35"/>
+          <p:cNvPr id="37" name="Rectangle 36"/>
           <p:cNvSpPr/>
           <p:nvPr/>
         </p:nvSpPr>
@@ -20316,7 +20498,7 @@
       </p:sp>
       <p:sp>
         <p:nvSpPr>
-          <p:cNvPr id="37" name="TextBox 36"/>
+          <p:cNvPr id="38" name="TextBox 37"/>
           <p:cNvSpPr txBox="1"/>
           <p:nvPr/>
         </p:nvSpPr>
@@ -20352,7 +20534,7 @@
       </p:sp>
       <p:sp>
         <p:nvSpPr>
-          <p:cNvPr id="38" name="Rounded Rectangle 37"/>
+          <p:cNvPr id="39" name="Rounded Rectangle 38"/>
           <p:cNvSpPr/>
           <p:nvPr/>
         </p:nvSpPr>
@@ -20397,7 +20579,7 @@
       </p:sp>
       <p:sp>
         <p:nvSpPr>
-          <p:cNvPr id="39" name="Rectangle 38"/>
+          <p:cNvPr id="40" name="Rectangle 39"/>
           <p:cNvSpPr/>
           <p:nvPr/>
         </p:nvSpPr>
@@ -20440,7 +20622,7 @@
       </p:sp>
       <p:sp>
         <p:nvSpPr>
-          <p:cNvPr id="40" name="Oval 39"/>
+          <p:cNvPr id="41" name="Oval 40"/>
           <p:cNvSpPr/>
           <p:nvPr/>
         </p:nvSpPr>
@@ -20485,7 +20667,7 @@
       </p:sp>
       <p:sp>
         <p:nvSpPr>
-          <p:cNvPr id="41" name="Oval 40"/>
+          <p:cNvPr id="42" name="Oval 41"/>
           <p:cNvSpPr/>
           <p:nvPr/>
         </p:nvSpPr>
@@ -20528,7 +20710,7 @@
       </p:sp>
       <p:sp>
         <p:nvSpPr>
-          <p:cNvPr id="42" name="TextBox 41"/>
+          <p:cNvPr id="43" name="TextBox 42"/>
           <p:cNvSpPr txBox="1"/>
           <p:nvPr/>
         </p:nvSpPr>
@@ -20564,7 +20746,7 @@
       </p:sp>
       <p:sp>
         <p:nvSpPr>
-          <p:cNvPr id="43" name="TextBox 42"/>
+          <p:cNvPr id="44" name="TextBox 43"/>
           <p:cNvSpPr txBox="1"/>
           <p:nvPr/>
         </p:nvSpPr>
@@ -20585,7 +20767,7 @@
           <a:lstStyle/>
           <a:p>
             <a:pPr algn="l">
-              <a:defRPr sz="1600" b="1" i="0">
+              <a:defRPr sz="1800" b="1" i="0">
                 <a:solidFill>
                   <a:srgbClr val="FFFFFF"/>
                 </a:solidFill>
@@ -20600,7 +20782,7 @@
       </p:sp>
       <p:sp>
         <p:nvSpPr>
-          <p:cNvPr id="44" name="Rectangle 43"/>
+          <p:cNvPr id="45" name="Rectangle 44"/>
           <p:cNvSpPr/>
           <p:nvPr/>
         </p:nvSpPr>
@@ -20643,7 +20825,7 @@
       </p:sp>
       <p:sp>
         <p:nvSpPr>
-          <p:cNvPr id="45" name="TextBox 44"/>
+          <p:cNvPr id="46" name="TextBox 45"/>
           <p:cNvSpPr txBox="1"/>
           <p:nvPr/>
         </p:nvSpPr>
@@ -20679,7 +20861,7 @@
       </p:sp>
       <p:sp>
         <p:nvSpPr>
-          <p:cNvPr id="46" name="Rounded Rectangle 45"/>
+          <p:cNvPr id="47" name="Rounded Rectangle 46"/>
           <p:cNvSpPr/>
           <p:nvPr/>
         </p:nvSpPr>
@@ -20724,7 +20906,7 @@
       </p:sp>
       <p:sp>
         <p:nvSpPr>
-          <p:cNvPr id="47" name="Rectangle 46"/>
+          <p:cNvPr id="48" name="Rectangle 47"/>
           <p:cNvSpPr/>
           <p:nvPr/>
         </p:nvSpPr>
@@ -20767,7 +20949,7 @@
       </p:sp>
       <p:sp>
         <p:nvSpPr>
-          <p:cNvPr id="48" name="Oval 47"/>
+          <p:cNvPr id="49" name="Oval 48"/>
           <p:cNvSpPr/>
           <p:nvPr/>
         </p:nvSpPr>
@@ -20812,7 +20994,7 @@
       </p:sp>
       <p:sp>
         <p:nvSpPr>
-          <p:cNvPr id="49" name="Oval 48"/>
+          <p:cNvPr id="50" name="Oval 49"/>
           <p:cNvSpPr/>
           <p:nvPr/>
         </p:nvSpPr>
@@ -20855,7 +21037,7 @@
       </p:sp>
       <p:sp>
         <p:nvSpPr>
-          <p:cNvPr id="50" name="TextBox 49"/>
+          <p:cNvPr id="51" name="TextBox 50"/>
           <p:cNvSpPr txBox="1"/>
           <p:nvPr/>
         </p:nvSpPr>
@@ -20891,7 +21073,7 @@
       </p:sp>
       <p:sp>
         <p:nvSpPr>
-          <p:cNvPr id="51" name="TextBox 50"/>
+          <p:cNvPr id="52" name="TextBox 51"/>
           <p:cNvSpPr txBox="1"/>
           <p:nvPr/>
         </p:nvSpPr>
@@ -20912,7 +21094,7 @@
           <a:lstStyle/>
           <a:p>
             <a:pPr algn="l">
-              <a:defRPr sz="1600" b="1" i="0">
+              <a:defRPr sz="1800" b="1" i="0">
                 <a:solidFill>
                   <a:srgbClr val="FFFFFF"/>
                 </a:solidFill>
@@ -20927,7 +21109,7 @@
       </p:sp>
       <p:sp>
         <p:nvSpPr>
-          <p:cNvPr id="52" name="Rectangle 51"/>
+          <p:cNvPr id="53" name="Rectangle 52"/>
           <p:cNvSpPr/>
           <p:nvPr/>
         </p:nvSpPr>
@@ -20970,7 +21152,7 @@
       </p:sp>
       <p:sp>
         <p:nvSpPr>
-          <p:cNvPr id="53" name="TextBox 52"/>
+          <p:cNvPr id="54" name="TextBox 53"/>
           <p:cNvSpPr txBox="1"/>
           <p:nvPr/>
         </p:nvSpPr>
@@ -21006,7 +21188,7 @@
       </p:sp>
       <p:sp>
         <p:nvSpPr>
-          <p:cNvPr id="54" name="Rounded Rectangle 53"/>
+          <p:cNvPr id="55" name="Rounded Rectangle 54"/>
           <p:cNvSpPr/>
           <p:nvPr/>
         </p:nvSpPr>
@@ -21051,7 +21233,7 @@
       </p:sp>
       <p:sp>
         <p:nvSpPr>
-          <p:cNvPr id="55" name="Rectangle 54"/>
+          <p:cNvPr id="56" name="Rectangle 55"/>
           <p:cNvSpPr/>
           <p:nvPr/>
         </p:nvSpPr>
@@ -21094,7 +21276,7 @@
       </p:sp>
       <p:sp>
         <p:nvSpPr>
-          <p:cNvPr id="56" name="Oval 55"/>
+          <p:cNvPr id="57" name="Oval 56"/>
           <p:cNvSpPr/>
           <p:nvPr/>
         </p:nvSpPr>
@@ -21139,7 +21321,7 @@
       </p:sp>
       <p:sp>
         <p:nvSpPr>
-          <p:cNvPr id="57" name="Oval 56"/>
+          <p:cNvPr id="58" name="Oval 57"/>
           <p:cNvSpPr/>
           <p:nvPr/>
         </p:nvSpPr>
@@ -21182,7 +21364,7 @@
       </p:sp>
       <p:sp>
         <p:nvSpPr>
-          <p:cNvPr id="58" name="TextBox 57"/>
+          <p:cNvPr id="59" name="TextBox 58"/>
           <p:cNvSpPr txBox="1"/>
           <p:nvPr/>
         </p:nvSpPr>
@@ -21218,7 +21400,7 @@
       </p:sp>
       <p:sp>
         <p:nvSpPr>
-          <p:cNvPr id="59" name="TextBox 58"/>
+          <p:cNvPr id="60" name="TextBox 59"/>
           <p:cNvSpPr txBox="1"/>
           <p:nvPr/>
         </p:nvSpPr>
@@ -21239,7 +21421,7 @@
           <a:lstStyle/>
           <a:p>
             <a:pPr algn="l">
-              <a:defRPr sz="1600" b="1" i="0">
+              <a:defRPr sz="1800" b="1" i="0">
                 <a:solidFill>
                   <a:srgbClr val="FFFFFF"/>
                 </a:solidFill>
@@ -21254,7 +21436,7 @@
       </p:sp>
       <p:sp>
         <p:nvSpPr>
-          <p:cNvPr id="60" name="Rectangle 59"/>
+          <p:cNvPr id="61" name="Rectangle 60"/>
           <p:cNvSpPr/>
           <p:nvPr/>
         </p:nvSpPr>
@@ -21297,7 +21479,7 @@
       </p:sp>
       <p:sp>
         <p:nvSpPr>
-          <p:cNvPr id="61" name="TextBox 60"/>
+          <p:cNvPr id="62" name="TextBox 61"/>
           <p:cNvSpPr txBox="1"/>
           <p:nvPr/>
         </p:nvSpPr>
@@ -21333,7 +21515,7 @@
       </p:sp>
       <p:sp>
         <p:nvSpPr>
-          <p:cNvPr id="62" name="Rounded Rectangle 61"/>
+          <p:cNvPr id="63" name="Rounded Rectangle 62"/>
           <p:cNvSpPr/>
           <p:nvPr/>
         </p:nvSpPr>
@@ -21378,7 +21560,7 @@
       </p:sp>
       <p:sp>
         <p:nvSpPr>
-          <p:cNvPr id="63" name="Rectangle 62"/>
+          <p:cNvPr id="64" name="Rectangle 63"/>
           <p:cNvSpPr/>
           <p:nvPr/>
         </p:nvSpPr>
@@ -21421,7 +21603,7 @@
       </p:sp>
       <p:sp>
         <p:nvSpPr>
-          <p:cNvPr id="64" name="Oval 63"/>
+          <p:cNvPr id="65" name="Oval 64"/>
           <p:cNvSpPr/>
           <p:nvPr/>
         </p:nvSpPr>
@@ -21466,7 +21648,7 @@
       </p:sp>
       <p:sp>
         <p:nvSpPr>
-          <p:cNvPr id="65" name="Oval 64"/>
+          <p:cNvPr id="66" name="Oval 65"/>
           <p:cNvSpPr/>
           <p:nvPr/>
         </p:nvSpPr>
@@ -21509,7 +21691,7 @@
       </p:sp>
       <p:sp>
         <p:nvSpPr>
-          <p:cNvPr id="66" name="TextBox 65"/>
+          <p:cNvPr id="67" name="TextBox 66"/>
           <p:cNvSpPr txBox="1"/>
           <p:nvPr/>
         </p:nvSpPr>
@@ -21545,7 +21727,7 @@
       </p:sp>
       <p:sp>
         <p:nvSpPr>
-          <p:cNvPr id="67" name="TextBox 66"/>
+          <p:cNvPr id="68" name="TextBox 67"/>
           <p:cNvSpPr txBox="1"/>
           <p:nvPr/>
         </p:nvSpPr>
@@ -21566,7 +21748,7 @@
           <a:lstStyle/>
           <a:p>
             <a:pPr algn="l">
-              <a:defRPr sz="1600" b="1" i="0">
+              <a:defRPr sz="1800" b="1" i="0">
                 <a:solidFill>
                   <a:srgbClr val="FFFFFF"/>
                 </a:solidFill>
@@ -21581,7 +21763,7 @@
       </p:sp>
       <p:sp>
         <p:nvSpPr>
-          <p:cNvPr id="68" name="Rectangle 67"/>
+          <p:cNvPr id="69" name="Rectangle 68"/>
           <p:cNvSpPr/>
           <p:nvPr/>
         </p:nvSpPr>
@@ -21624,7 +21806,7 @@
       </p:sp>
       <p:sp>
         <p:nvSpPr>
-          <p:cNvPr id="69" name="TextBox 68"/>
+          <p:cNvPr id="70" name="TextBox 69"/>
           <p:cNvSpPr txBox="1"/>
           <p:nvPr/>
         </p:nvSpPr>
@@ -21660,7 +21842,7 @@
       </p:sp>
       <p:sp>
         <p:nvSpPr>
-          <p:cNvPr id="70" name="Rounded Rectangle 69"/>
+          <p:cNvPr id="71" name="Rounded Rectangle 70"/>
           <p:cNvSpPr/>
           <p:nvPr/>
         </p:nvSpPr>
@@ -21705,7 +21887,7 @@
       </p:sp>
       <p:sp>
         <p:nvSpPr>
-          <p:cNvPr id="71" name="Rectangle 70"/>
+          <p:cNvPr id="72" name="Rectangle 71"/>
           <p:cNvSpPr/>
           <p:nvPr/>
         </p:nvSpPr>
@@ -21748,7 +21930,7 @@
       </p:sp>
       <p:sp>
         <p:nvSpPr>
-          <p:cNvPr id="72" name="Oval 71"/>
+          <p:cNvPr id="73" name="Oval 72"/>
           <p:cNvSpPr/>
           <p:nvPr/>
         </p:nvSpPr>
@@ -21793,7 +21975,7 @@
       </p:sp>
       <p:sp>
         <p:nvSpPr>
-          <p:cNvPr id="73" name="Oval 72"/>
+          <p:cNvPr id="74" name="Oval 73"/>
           <p:cNvSpPr/>
           <p:nvPr/>
         </p:nvSpPr>
@@ -21836,7 +22018,7 @@
       </p:sp>
       <p:sp>
         <p:nvSpPr>
-          <p:cNvPr id="74" name="TextBox 73"/>
+          <p:cNvPr id="75" name="TextBox 74"/>
           <p:cNvSpPr txBox="1"/>
           <p:nvPr/>
         </p:nvSpPr>
@@ -21872,7 +22054,7 @@
       </p:sp>
       <p:sp>
         <p:nvSpPr>
-          <p:cNvPr id="75" name="TextBox 74"/>
+          <p:cNvPr id="76" name="TextBox 75"/>
           <p:cNvSpPr txBox="1"/>
           <p:nvPr/>
         </p:nvSpPr>
@@ -21893,7 +22075,7 @@
           <a:lstStyle/>
           <a:p>
             <a:pPr algn="l">
-              <a:defRPr sz="1600" b="1" i="0">
+              <a:defRPr sz="1800" b="1" i="0">
                 <a:solidFill>
                   <a:srgbClr val="FFFFFF"/>
                 </a:solidFill>
@@ -21908,7 +22090,7 @@
       </p:sp>
       <p:sp>
         <p:nvSpPr>
-          <p:cNvPr id="76" name="Rectangle 75"/>
+          <p:cNvPr id="77" name="Rectangle 76"/>
           <p:cNvSpPr/>
           <p:nvPr/>
         </p:nvSpPr>
@@ -21951,7 +22133,7 @@
       </p:sp>
       <p:sp>
         <p:nvSpPr>
-          <p:cNvPr id="77" name="TextBox 76"/>
+          <p:cNvPr id="78" name="TextBox 77"/>
           <p:cNvSpPr txBox="1"/>
           <p:nvPr/>
         </p:nvSpPr>
@@ -21987,7 +22169,7 @@
       </p:sp>
       <p:sp>
         <p:nvSpPr>
-          <p:cNvPr id="78" name="Rounded Rectangle 77"/>
+          <p:cNvPr id="79" name="Rounded Rectangle 78"/>
           <p:cNvSpPr/>
           <p:nvPr/>
         </p:nvSpPr>
@@ -22032,7 +22214,7 @@
       </p:sp>
       <p:sp>
         <p:nvSpPr>
-          <p:cNvPr id="79" name="Rectangle 78"/>
+          <p:cNvPr id="80" name="Rectangle 79"/>
           <p:cNvSpPr/>
           <p:nvPr/>
         </p:nvSpPr>
@@ -22075,7 +22257,7 @@
       </p:sp>
       <p:sp>
         <p:nvSpPr>
-          <p:cNvPr id="80" name="Oval 79"/>
+          <p:cNvPr id="81" name="Oval 80"/>
           <p:cNvSpPr/>
           <p:nvPr/>
         </p:nvSpPr>
@@ -22120,7 +22302,7 @@
       </p:sp>
       <p:sp>
         <p:nvSpPr>
-          <p:cNvPr id="81" name="Oval 80"/>
+          <p:cNvPr id="82" name="Oval 81"/>
           <p:cNvSpPr/>
           <p:nvPr/>
         </p:nvSpPr>
@@ -22163,7 +22345,7 @@
       </p:sp>
       <p:sp>
         <p:nvSpPr>
-          <p:cNvPr id="82" name="TextBox 81"/>
+          <p:cNvPr id="83" name="TextBox 82"/>
           <p:cNvSpPr txBox="1"/>
           <p:nvPr/>
         </p:nvSpPr>
@@ -22199,7 +22381,7 @@
       </p:sp>
       <p:sp>
         <p:nvSpPr>
-          <p:cNvPr id="83" name="TextBox 82"/>
+          <p:cNvPr id="84" name="TextBox 83"/>
           <p:cNvSpPr txBox="1"/>
           <p:nvPr/>
         </p:nvSpPr>
@@ -22220,7 +22402,7 @@
           <a:lstStyle/>
           <a:p>
             <a:pPr algn="l">
-              <a:defRPr sz="1600" b="1" i="0">
+              <a:defRPr sz="1800" b="1" i="0">
                 <a:solidFill>
                   <a:srgbClr val="FFFFFF"/>
                 </a:solidFill>
@@ -22235,7 +22417,7 @@
       </p:sp>
       <p:sp>
         <p:nvSpPr>
-          <p:cNvPr id="84" name="Rectangle 83"/>
+          <p:cNvPr id="85" name="Rectangle 84"/>
           <p:cNvSpPr/>
           <p:nvPr/>
         </p:nvSpPr>
@@ -22278,7 +22460,7 @@
       </p:sp>
       <p:sp>
         <p:nvSpPr>
-          <p:cNvPr id="85" name="TextBox 84"/>
+          <p:cNvPr id="86" name="TextBox 85"/>
           <p:cNvSpPr txBox="1"/>
           <p:nvPr/>
         </p:nvSpPr>
@@ -22314,7 +22496,7 @@
       </p:sp>
       <p:sp>
         <p:nvSpPr>
-          <p:cNvPr id="86" name="Oval 85"/>
+          <p:cNvPr id="87" name="Oval 86"/>
           <p:cNvSpPr/>
           <p:nvPr/>
         </p:nvSpPr>
@@ -22359,7 +22541,7 @@
       </p:sp>
       <p:sp>
         <p:nvSpPr>
-          <p:cNvPr id="87" name="Oval 86"/>
+          <p:cNvPr id="88" name="Oval 87"/>
           <p:cNvSpPr/>
           <p:nvPr/>
         </p:nvSpPr>
@@ -22404,7 +22586,7 @@
       </p:sp>
       <p:sp>
         <p:nvSpPr>
-          <p:cNvPr id="88" name="Oval 87"/>
+          <p:cNvPr id="89" name="Oval 88"/>
           <p:cNvSpPr/>
           <p:nvPr/>
         </p:nvSpPr>
@@ -22449,7 +22631,7 @@
       </p:sp>
       <p:sp>
         <p:nvSpPr>
-          <p:cNvPr id="89" name="Oval 88"/>
+          <p:cNvPr id="90" name="Oval 89"/>
           <p:cNvSpPr/>
           <p:nvPr/>
         </p:nvSpPr>
@@ -22494,7 +22676,7 @@
       </p:sp>
       <p:sp>
         <p:nvSpPr>
-          <p:cNvPr id="90" name="Oval 89"/>
+          <p:cNvPr id="91" name="Oval 90"/>
           <p:cNvSpPr/>
           <p:nvPr/>
         </p:nvSpPr>
@@ -22539,7 +22721,7 @@
       </p:sp>
       <p:sp>
         <p:nvSpPr>
-          <p:cNvPr id="91" name="Oval 90"/>
+          <p:cNvPr id="92" name="Oval 91"/>
           <p:cNvSpPr/>
           <p:nvPr/>
         </p:nvSpPr>
@@ -22584,7 +22766,7 @@
       </p:sp>
       <p:sp>
         <p:nvSpPr>
-          <p:cNvPr id="92" name="Oval 91"/>
+          <p:cNvPr id="93" name="Oval 92"/>
           <p:cNvSpPr/>
           <p:nvPr/>
         </p:nvSpPr>
@@ -22629,7 +22811,7 @@
       </p:sp>
       <p:sp>
         <p:nvSpPr>
-          <p:cNvPr id="93" name="Oval 92"/>
+          <p:cNvPr id="94" name="Oval 93"/>
           <p:cNvSpPr/>
           <p:nvPr/>
         </p:nvSpPr>
@@ -22674,7 +22856,7 @@
       </p:sp>
       <p:sp>
         <p:nvSpPr>
-          <p:cNvPr id="94" name="Oval 93"/>
+          <p:cNvPr id="95" name="Oval 94"/>
           <p:cNvSpPr/>
           <p:nvPr/>
         </p:nvSpPr>
@@ -22719,7 +22901,7 @@
       </p:sp>
       <p:sp>
         <p:nvSpPr>
-          <p:cNvPr id="95" name="Oval 94"/>
+          <p:cNvPr id="96" name="Oval 95"/>
           <p:cNvSpPr/>
           <p:nvPr/>
         </p:nvSpPr>
@@ -22764,7 +22946,7 @@
       </p:sp>
       <p:sp>
         <p:nvSpPr>
-          <p:cNvPr id="96" name="Oval 95"/>
+          <p:cNvPr id="97" name="Oval 96"/>
           <p:cNvSpPr/>
           <p:nvPr/>
         </p:nvSpPr>
@@ -22809,7 +22991,7 @@
       </p:sp>
       <p:sp>
         <p:nvSpPr>
-          <p:cNvPr id="97" name="Oval 96"/>
+          <p:cNvPr id="98" name="Oval 97"/>
           <p:cNvSpPr/>
           <p:nvPr/>
         </p:nvSpPr>
@@ -22854,7 +23036,7 @@
       </p:sp>
       <p:sp>
         <p:nvSpPr>
-          <p:cNvPr id="98" name="Oval 97"/>
+          <p:cNvPr id="99" name="Oval 98"/>
           <p:cNvSpPr/>
           <p:nvPr/>
         </p:nvSpPr>
@@ -22899,7 +23081,7 @@
       </p:sp>
       <p:sp>
         <p:nvSpPr>
-          <p:cNvPr id="99" name="Oval 98"/>
+          <p:cNvPr id="100" name="Oval 99"/>
           <p:cNvSpPr/>
           <p:nvPr/>
         </p:nvSpPr>
@@ -22944,7 +23126,7 @@
       </p:sp>
       <p:sp>
         <p:nvSpPr>
-          <p:cNvPr id="100" name="Oval 99"/>
+          <p:cNvPr id="101" name="Oval 100"/>
           <p:cNvSpPr/>
           <p:nvPr/>
         </p:nvSpPr>
@@ -22989,7 +23171,7 @@
       </p:sp>
       <p:sp>
         <p:nvSpPr>
-          <p:cNvPr id="101" name="Oval 100"/>
+          <p:cNvPr id="102" name="Oval 101"/>
           <p:cNvSpPr/>
           <p:nvPr/>
         </p:nvSpPr>
@@ -23034,7 +23216,7 @@
       </p:sp>
       <p:sp>
         <p:nvSpPr>
-          <p:cNvPr id="102" name="TextBox 101"/>
+          <p:cNvPr id="103" name="TextBox 102"/>
           <p:cNvSpPr txBox="1"/>
           <p:nvPr/>
         </p:nvSpPr>
@@ -23070,7 +23252,7 @@
       </p:sp>
       <p:sp>
         <p:nvSpPr>
-          <p:cNvPr id="103" name="Rectangle 102"/>
+          <p:cNvPr id="104" name="Rectangle 103"/>
           <p:cNvSpPr/>
           <p:nvPr/>
         </p:nvSpPr>
@@ -23113,7 +23295,7 @@
       </p:sp>
       <p:sp>
         <p:nvSpPr>
-          <p:cNvPr id="104" name="TextBox 103"/>
+          <p:cNvPr id="105" name="TextBox 104"/>
           <p:cNvSpPr txBox="1"/>
           <p:nvPr/>
         </p:nvSpPr>
@@ -23149,7 +23331,7 @@
       </p:sp>
       <p:pic>
         <p:nvPicPr>
-          <p:cNvPr id="105" name="Picture 104" descr="logo-wolf.png"/>
+          <p:cNvPr id="106" name="Picture 105" descr="logo-wolf.png"/>
           <p:cNvPicPr>
             <a:picLocks noChangeAspect="1"/>
           </p:cNvPicPr>

</xml_diff>